<commit_message>
sync docs/ from travplan@0a05e90
</commit_message>
<xml_diff>
--- a/slides/research-overview/research-overview.pptx
+++ b/slides/research-overview/research-overview.pptx
@@ -6700,7 +6700,7 @@
                 <a:ea typeface="Malgun Gothic"/>
                 <a:cs typeface="Malgun Gothic"/>
               </a:rPr>
-              <a:t> 문서마다 첫 탭이 개요(분야 계보, 공개 코드·모델 현황, travplan의 위치)이고, 그 뒤가 주제별 탭이다. 절 번호는 문서를 옮겨도 그대로 둔다(인식 A, Planner B, Controller E와 안전 필터 C, 시뮬레이션 S, 배경 0, 강화학습 R, 참고문헌 D).</a:t>
+              <a:t> 문서마다 첫 탭이 개요(분야 계보, 공개 코드·모델 현황, travplan의 위치)이고, 그 뒤가 주제별 탭이다. 절 번호는 문서를 옮겨도 그대로 둔다(인식 A, Planner B, Controller E와 안전 필터 C, 시뮬레이션 S, 배경 0, 강화학습 R, 딥러닝 L, 참고문헌 D).</a:t>
             </a:r>
           </a:p>
         </p:txBody>
@@ -6715,7 +6715,7 @@
         </p:nvGraphicFramePr>
         <p:xfrm>
           <a:off x="609600" y="4618633"/>
-          <a:ext cx="10966450" cy="1271904"/>
+          <a:ext cx="10966451" cy="1271904"/>
         </p:xfrm>
         <a:graphic>
           <a:graphicData uri="http://schemas.openxmlformats.org/drawingml/2006/table">
@@ -6724,10 +6724,10 @@
                 <a:tableStyleId>{5C22544A-7EE6-4342-B048-85BDC9FD1C3A}</a:tableStyleId>
               </a:tblPr>
               <a:tblGrid>
-                <a:gridCol w="921941"/>
-                <a:gridCol w="5559127"/>
-                <a:gridCol w="2005409"/>
-                <a:gridCol w="2479973"/>
+                <a:gridCol w="890191"/>
+                <a:gridCol w="4991100"/>
+                <a:gridCol w="2763441"/>
+                <a:gridCol w="2321719"/>
               </a:tblGrid>
               <a:tr h="197088">
                 <a:tc>
@@ -7316,7 +7316,7 @@
         </p:nvGraphicFramePr>
         <p:xfrm>
           <a:off x="609600" y="1244600"/>
-          <a:ext cx="10966450" cy="1348104"/>
+          <a:ext cx="10966451" cy="1907856"/>
         </p:xfrm>
         <a:graphic>
           <a:graphicData uri="http://schemas.openxmlformats.org/drawingml/2006/table">
@@ -7325,10 +7325,10 @@
                 <a:tableStyleId>{5C22544A-7EE6-4342-B048-85BDC9FD1C3A}</a:tableStyleId>
               </a:tblPr>
               <a:tblGrid>
-                <a:gridCol w="921941"/>
-                <a:gridCol w="5559127"/>
-                <a:gridCol w="2005409"/>
-                <a:gridCol w="2479973"/>
+                <a:gridCol w="890191"/>
+                <a:gridCol w="4991100"/>
+                <a:gridCol w="2763441"/>
+                <a:gridCol w="2321719"/>
               </a:tblGrid>
               <a:tr h="197088">
                 <a:tc>
@@ -7428,7 +7428,7 @@
                   </a:tcPr>
                 </a:tc>
               </a:tr>
-              <a:tr h="197088">
+              <a:tr h="317976">
                 <a:tc>
                   <a:txBody>
                     <a:bodyPr wrap="square"/>
@@ -7722,6 +7722,104 @@
                   </a:tcPr>
                 </a:tc>
               </a:tr>
+              <a:tr h="438864">
+                <a:tc>
+                  <a:txBody>
+                    <a:bodyPr wrap="square"/>
+                    <a:lstStyle/>
+                    <a:p>
+                      <a:r>
+                        <a:rPr sz="800" b="0" i="0">
+                          <a:solidFill>
+                            <a:srgbClr val="16213A"/>
+                          </a:solidFill>
+                          <a:latin typeface="Arial"/>
+                          <a:ea typeface="Malgun Gothic"/>
+                          <a:cs typeface="Malgun Gothic"/>
+                        </a:rPr>
+                        <a:t>딥러닝 (§L)</a:t>
+                      </a:r>
+                    </a:p>
+                  </a:txBody>
+                  <a:tcPr marL="63500" marR="63500" marT="12700" marB="12700">
+                    <a:solidFill>
+                      <a:srgbClr val="F3F0E8"/>
+                    </a:solidFill>
+                  </a:tcPr>
+                </a:tc>
+                <a:tc>
+                  <a:txBody>
+                    <a:bodyPr wrap="square"/>
+                    <a:lstStyle/>
+                    <a:p>
+                      <a:r>
+                        <a:rPr sz="800" b="0" i="0">
+                          <a:solidFill>
+                            <a:srgbClr val="16213A"/>
+                          </a:solidFill>
+                          <a:latin typeface="Arial"/>
+                          <a:ea typeface="Malgun Gothic"/>
+                          <a:cs typeface="Malgun Gothic"/>
+                        </a:rPr>
+                        <a:t>개요(L.0), 기초(L.1–L.3), 구조(L.4–L.8), 생성 모델(L.9–L.13), 자기지도·규모(L.14–L.18), 멀티모달·로봇(L.19–L.21), travplan에서(L.22)</a:t>
+                      </a:r>
+                    </a:p>
+                  </a:txBody>
+                  <a:tcPr marL="63500" marR="63500" marT="12700" marB="12700">
+                    <a:solidFill>
+                      <a:srgbClr val="F3F0E8"/>
+                    </a:solidFill>
+                  </a:tcPr>
+                </a:tc>
+                <a:tc>
+                  <a:txBody>
+                    <a:bodyPr wrap="square"/>
+                    <a:lstStyle/>
+                    <a:p>
+                      <a:r>
+                        <a:rPr sz="800" b="0" i="0">
+                          <a:solidFill>
+                            <a:srgbClr val="16213A"/>
+                          </a:solidFill>
+                          <a:latin typeface="Arial"/>
+                          <a:ea typeface="Malgun Gothic"/>
+                          <a:cs typeface="Malgun Gothic"/>
+                        </a:rPr>
+                        <a:t>교재 Understanding Deep Learning과 MIT 6.S184·Stanford CS336을 뼈대로 한 딥러닝 개념. 장난감 문제를 실제로 풀어 그린 그림</a:t>
+                      </a:r>
+                    </a:p>
+                  </a:txBody>
+                  <a:tcPr marL="63500" marR="63500" marT="12700" marB="12700">
+                    <a:solidFill>
+                      <a:srgbClr val="F3F0E8"/>
+                    </a:solidFill>
+                  </a:tcPr>
+                </a:tc>
+                <a:tc>
+                  <a:txBody>
+                    <a:bodyPr wrap="square"/>
+                    <a:lstStyle/>
+                    <a:p>
+                      <a:r>
+                        <a:rPr sz="800" b="0" i="0">
+                          <a:solidFill>
+                            <a:srgbClr val="16213A"/>
+                          </a:solidFill>
+                          <a:latin typeface="Arial"/>
+                          <a:ea typeface="Malgun Gothic"/>
+                          <a:cs typeface="Malgun Gothic"/>
+                        </a:rPr>
+                        <a:t>Planner D(flow matching), Joint Planner(DiT식 transformer), TravNet, TinyPolicy의 구조와 학습</a:t>
+                      </a:r>
+                    </a:p>
+                  </a:txBody>
+                  <a:tcPr marL="63500" marR="63500" marT="12700" marB="12700">
+                    <a:solidFill>
+                      <a:srgbClr val="F3F0E8"/>
+                    </a:solidFill>
+                  </a:tcPr>
+                </a:tc>
+              </a:tr>
               <a:tr h="317976">
                 <a:tc>
                   <a:txBody>
@@ -7743,7 +7841,7 @@
                   </a:txBody>
                   <a:tcPr marL="63500" marR="63500" marT="12700" marB="12700">
                     <a:solidFill>
-                      <a:srgbClr val="F3F0E8"/>
+                      <a:srgbClr val="FFFDF8"/>
                     </a:solidFill>
                   </a:tcPr>
                 </a:tc>
@@ -7767,7 +7865,7 @@
                   </a:txBody>
                   <a:tcPr marL="63500" marR="63500" marT="12700" marB="12700">
                     <a:solidFill>
-                      <a:srgbClr val="F3F0E8"/>
+                      <a:srgbClr val="FFFDF8"/>
                     </a:solidFill>
                   </a:tcPr>
                 </a:tc>
@@ -7791,7 +7889,7 @@
                   </a:txBody>
                   <a:tcPr marL="63500" marR="63500" marT="12700" marB="12700">
                     <a:solidFill>
-                      <a:srgbClr val="F3F0E8"/>
+                      <a:srgbClr val="FFFDF8"/>
                     </a:solidFill>
                   </a:tcPr>
                 </a:tc>
@@ -7815,7 +7913,7 @@
                   </a:txBody>
                   <a:tcPr marL="63500" marR="63500" marT="12700" marB="12700">
                     <a:solidFill>
-                      <a:srgbClr val="F3F0E8"/>
+                      <a:srgbClr val="FFFDF8"/>
                     </a:solidFill>
                   </a:tcPr>
                 </a:tc>
@@ -7832,7 +7930,7 @@
         </p:nvSpPr>
         <p:spPr>
           <a:xfrm>
-            <a:off x="609600" y="3024981"/>
+            <a:off x="609600" y="3724672"/>
             <a:ext cx="10972800" cy="432991"/>
           </a:xfrm>
           <a:prstGeom prst="rect">
@@ -7881,8 +7979,8 @@
           <p:nvPr/>
         </p:nvGraphicFramePr>
         <p:xfrm>
-          <a:off x="609600" y="3546872"/>
-          <a:ext cx="10966449" cy="1786968"/>
+          <a:off x="609600" y="4246562"/>
+          <a:ext cx="10966449" cy="1468992"/>
         </p:xfrm>
         <a:graphic>
           <a:graphicData uri="http://schemas.openxmlformats.org/drawingml/2006/table">
@@ -8503,128 +8601,6 @@
                   <a:tcPr marL="63500" marR="63500" marT="12700" marB="12700">
                     <a:solidFill>
                       <a:srgbClr val="F3F0E8"/>
-                    </a:solidFill>
-                  </a:tcPr>
-                </a:tc>
-              </a:tr>
-              <a:tr h="317976">
-                <a:tc>
-                  <a:txBody>
-                    <a:bodyPr wrap="square"/>
-                    <a:lstStyle/>
-                    <a:p>
-                      <a:r>
-                        <a:rPr sz="800" b="0" i="0">
-                          <a:solidFill>
-                            <a:srgbClr val="16213A"/>
-                          </a:solidFill>
-                          <a:latin typeface="Arial"/>
-                          <a:ea typeface="Malgun Gothic"/>
-                          <a:cs typeface="Malgun Gothic"/>
-                        </a:rPr>
-                        <a:t>2021–2022</a:t>
-                      </a:r>
-                    </a:p>
-                  </a:txBody>
-                  <a:tcPr marL="63500" marR="63500" marT="12700" marB="12700">
-                    <a:solidFill>
-                      <a:srgbClr val="FFFDF8"/>
-                    </a:solidFill>
-                  </a:tcPr>
-                </a:tc>
-                <a:tc>
-                  <a:txBody>
-                    <a:bodyPr wrap="square"/>
-                    <a:lstStyle/>
-                    <a:p>
-                      <a:r>
-                        <a:rPr sz="800" b="0" i="0">
-                          <a:solidFill>
-                            <a:srgbClr val="16213A"/>
-                          </a:solidFill>
-                          <a:latin typeface="Arial"/>
-                          <a:ea typeface="Malgun Gothic"/>
-                          <a:cs typeface="Malgun Gothic"/>
-                        </a:rPr>
-                        <a:t>BEVFormer, BEVFusion, MonoScene, elevation_mapping_cupy, ByteTrack, BoT-SORT</a:t>
-                      </a:r>
-                    </a:p>
-                  </a:txBody>
-                  <a:tcPr marL="63500" marR="63500" marT="12700" marB="12700">
-                    <a:solidFill>
-                      <a:srgbClr val="FFFDF8"/>
-                    </a:solidFill>
-                  </a:tcPr>
-                </a:tc>
-                <a:tc>
-                  <a:txBody>
-                    <a:bodyPr wrap="square"/>
-                    <a:lstStyle/>
-                    <a:p>
-                      <a:r>
-                        <a:rPr sz="800" b="0" i="0">
-                          <a:solidFill>
-                            <a:srgbClr val="16213A"/>
-                          </a:solidFill>
-                          <a:latin typeface="Arial"/>
-                          <a:ea typeface="Malgun Gothic"/>
-                          <a:cs typeface="Malgun Gothic"/>
-                        </a:rPr>
-                        <a:t>Diffuser, GNM, FAR Planner, PUTN</a:t>
-                      </a:r>
-                    </a:p>
-                  </a:txBody>
-                  <a:tcPr marL="63500" marR="63500" marT="12700" marB="12700">
-                    <a:solidFill>
-                      <a:srgbClr val="FFFDF8"/>
-                    </a:solidFill>
-                  </a:tcPr>
-                </a:tc>
-                <a:tc>
-                  <a:txBody>
-                    <a:bodyPr wrap="square"/>
-                    <a:lstStyle/>
-                    <a:p>
-                      <a:r>
-                        <a:rPr sz="800" b="0" i="0">
-                          <a:solidFill>
-                            <a:srgbClr val="16213A"/>
-                          </a:solidFill>
-                          <a:latin typeface="Arial"/>
-                          <a:ea typeface="Malgun Gothic"/>
-                          <a:cs typeface="Malgun Gothic"/>
-                        </a:rPr>
-                        <a:t>Robust MPPI, IKD, RMA, log-MPPI, SMPPI</a:t>
-                      </a:r>
-                    </a:p>
-                  </a:txBody>
-                  <a:tcPr marL="63500" marR="63500" marT="12700" marB="12700">
-                    <a:solidFill>
-                      <a:srgbClr val="FFFDF8"/>
-                    </a:solidFill>
-                  </a:tcPr>
-                </a:tc>
-                <a:tc>
-                  <a:txBody>
-                    <a:bodyPr wrap="square"/>
-                    <a:lstStyle/>
-                    <a:p>
-                      <a:r>
-                        <a:rPr sz="800" b="0" i="0">
-                          <a:solidFill>
-                            <a:srgbClr val="16213A"/>
-                          </a:solidFill>
-                          <a:latin typeface="Arial"/>
-                          <a:ea typeface="Malgun Gothic"/>
-                          <a:cs typeface="Malgun Gothic"/>
-                        </a:rPr>
-                        <a:t>Learning to Walk in Minutes, ART/ATK</a:t>
-                      </a:r>
-                    </a:p>
-                  </a:txBody>
-                  <a:tcPr marL="63500" marR="63500" marT="12700" marB="12700">
-                    <a:solidFill>
-                      <a:srgbClr val="FFFDF8"/>
                     </a:solidFill>
                   </a:tcPr>
                 </a:tc>
@@ -8791,7 +8767,7 @@
         </p:nvGraphicFramePr>
         <p:xfrm>
           <a:off x="609600" y="1244600"/>
-          <a:ext cx="10966449" cy="1468992"/>
+          <a:ext cx="10966449" cy="1786968"/>
         </p:xfrm>
         <a:graphic>
           <a:graphicData uri="http://schemas.openxmlformats.org/drawingml/2006/table">
@@ -8943,7 +8919,7 @@
                           <a:ea typeface="Malgun Gothic"/>
                           <a:cs typeface="Malgun Gothic"/>
                         </a:rPr>
-                        <a:t>2023</a:t>
+                        <a:t>2021–2022</a:t>
                       </a:r>
                     </a:p>
                   </a:txBody>
@@ -8967,7 +8943,7 @@
                           <a:ea typeface="Malgun Gothic"/>
                           <a:cs typeface="Malgun Gothic"/>
                         </a:rPr>
-                        <a:t>DINOv2, Grounding DINO, Occ3D, WVN, RT-DETR</a:t>
+                        <a:t>BEVFormer, BEVFusion, MonoScene, elevation_mapping_cupy, ByteTrack, BoT-SORT</a:t>
                       </a:r>
                     </a:p>
                   </a:txBody>
@@ -8991,7 +8967,7 @@
                           <a:ea typeface="Malgun Gothic"/>
                           <a:cs typeface="Malgun Gothic"/>
                         </a:rPr>
-                        <a:t>iPlanner, ViNT, NoMaD, Diffusion Policy, MPD, UniAD, VAD, PDM-Closed, ArtPlanner</a:t>
+                        <a:t>Diffuser, GNM, FAR Planner, PUTN</a:t>
                       </a:r>
                     </a:p>
                   </a:txBody>
@@ -9015,7 +8991,7 @@
                           <a:ea typeface="Malgun Gothic"/>
                           <a:cs typeface="Malgun Gothic"/>
                         </a:rPr>
-                        <a:t>TD-MPC2, 안전 필터 통합 관점</a:t>
+                        <a:t>Robust MPPI, IKD, RMA, log-MPPI, SMPPI</a:t>
                       </a:r>
                     </a:p>
                   </a:txBody>
@@ -9039,7 +9015,7 @@
                           <a:ea typeface="Malgun Gothic"/>
                           <a:cs typeface="Malgun Gothic"/>
                         </a:rPr>
-                        <a:t>HuNavSim, Gazebo Harmonic</a:t>
+                        <a:t>Learning to Walk in Minutes, ART/ATK</a:t>
                       </a:r>
                     </a:p>
                   </a:txBody>
@@ -9065,7 +9041,7 @@
                           <a:ea typeface="Malgun Gothic"/>
                           <a:cs typeface="Malgun Gothic"/>
                         </a:rPr>
-                        <a:t>2024</a:t>
+                        <a:t>2023</a:t>
                       </a:r>
                     </a:p>
                   </a:txBody>
@@ -9089,7 +9065,7 @@
                           <a:ea typeface="Malgun Gothic"/>
                           <a:cs typeface="Malgun Gothic"/>
                         </a:rPr>
-                        <a:t>Depth Anything V2, SAM 2, V-STRONG, RoadRunner, YOLOv10, D-FINE</a:t>
+                        <a:t>DINOv2, Grounding DINO, Occ3D, WVN, RT-DETR</a:t>
                       </a:r>
                     </a:p>
                   </a:txBody>
@@ -9113,7 +9089,7 @@
                           <a:ea typeface="Malgun Gothic"/>
                           <a:cs typeface="Malgun Gothic"/>
                         </a:rPr>
-                        <a:t>ViPlanner, OpenVLA, π0, NaVILA, CityWalker, DiffusionDrive, NAVSIM, Hydra-MDP</a:t>
+                        <a:t>iPlanner, ViNT, NoMaD, Diffusion Policy, MPD, UniAD, VAD, PDM-Closed, ArtPlanner</a:t>
                       </a:r>
                     </a:p>
                   </a:txBody>
@@ -9137,7 +9113,7 @@
                           <a:ea typeface="Malgun Gothic"/>
                           <a:cs typeface="Malgun Gothic"/>
                         </a:rPr>
-                        <a:t>MPPI-Generic</a:t>
+                        <a:t>TD-MPC2, 안전 필터 통합 관점</a:t>
                       </a:r>
                     </a:p>
                   </a:txBody>
@@ -9161,7 +9137,7 @@
                           <a:ea typeface="Malgun Gothic"/>
                           <a:cs typeface="Malgun Gothic"/>
                         </a:rPr>
-                        <a:t>MetaUrban, Arena 4.0, X-Mobility, Navigation World Models</a:t>
+                        <a:t>HuNavSim, Gazebo Harmonic</a:t>
                       </a:r>
                     </a:p>
                   </a:txBody>
@@ -9187,7 +9163,7 @@
                           <a:ea typeface="Malgun Gothic"/>
                           <a:cs typeface="Malgun Gothic"/>
                         </a:rPr>
-                        <a:t>2025</a:t>
+                        <a:t>2024</a:t>
                       </a:r>
                     </a:p>
                   </a:txBody>
@@ -9211,7 +9187,7 @@
                           <a:ea typeface="Malgun Gothic"/>
                           <a:cs typeface="Malgun Gothic"/>
                         </a:rPr>
-                        <a:t>DINOv3, Depth Anything 3, SAM 3, RF-DETR, MoFlow</a:t>
+                        <a:t>Depth Anything V2, SAM 2, V-STRONG, RoadRunner, YOLOv10, D-FINE</a:t>
                       </a:r>
                     </a:p>
                   </a:txBody>
@@ -9235,7 +9211,7 @@
                           <a:ea typeface="Malgun Gothic"/>
                           <a:cs typeface="Malgun Gothic"/>
                         </a:rPr>
-                        <a:t>Diffusion Planner, GoalFlow, NavDP, CaRL, Alpamayo, MolmoAct, VAMOS, FPO</a:t>
+                        <a:t>ViPlanner, OpenVLA, π0, NaVILA, CityWalker, DiffusionDrive, NAVSIM, Hydra-MDP</a:t>
                       </a:r>
                     </a:p>
                   </a:txBody>
@@ -9259,7 +9235,7 @@
                           <a:ea typeface="Malgun Gothic"/>
                           <a:cs typeface="Malgun Gothic"/>
                         </a:rPr>
-                        <a:t>CVaR-BF, DRA-MPPI</a:t>
+                        <a:t>MPPI-Generic</a:t>
                       </a:r>
                     </a:p>
                   </a:txBody>
@@ -9283,7 +9259,7 @@
                           <a:ea typeface="Malgun Gothic"/>
                           <a:cs typeface="Malgun Gothic"/>
                         </a:rPr>
-                        <a:t>Isaac Lab, MuJoCo Playground, URBAN-SIM, UrbanVerse, COMPASS, Cosmos</a:t>
+                        <a:t>MetaUrban, Arena 4.0, X-Mobility, Navigation World Models</a:t>
                       </a:r>
                     </a:p>
                   </a:txBody>
@@ -9309,13 +9285,135 @@
                           <a:ea typeface="Malgun Gothic"/>
                           <a:cs typeface="Malgun Gothic"/>
                         </a:rPr>
+                        <a:t>2025</a:t>
+                      </a:r>
+                    </a:p>
+                  </a:txBody>
+                  <a:tcPr marL="63500" marR="63500" marT="12700" marB="12700">
+                    <a:solidFill>
+                      <a:srgbClr val="F3F0E8"/>
+                    </a:solidFill>
+                  </a:tcPr>
+                </a:tc>
+                <a:tc>
+                  <a:txBody>
+                    <a:bodyPr wrap="square"/>
+                    <a:lstStyle/>
+                    <a:p>
+                      <a:r>
+                        <a:rPr sz="800" b="0" i="0">
+                          <a:solidFill>
+                            <a:srgbClr val="16213A"/>
+                          </a:solidFill>
+                          <a:latin typeface="Arial"/>
+                          <a:ea typeface="Malgun Gothic"/>
+                          <a:cs typeface="Malgun Gothic"/>
+                        </a:rPr>
+                        <a:t>DINOv3, Depth Anything 3, SAM 3, RF-DETR, MoFlow</a:t>
+                      </a:r>
+                    </a:p>
+                  </a:txBody>
+                  <a:tcPr marL="63500" marR="63500" marT="12700" marB="12700">
+                    <a:solidFill>
+                      <a:srgbClr val="F3F0E8"/>
+                    </a:solidFill>
+                  </a:tcPr>
+                </a:tc>
+                <a:tc>
+                  <a:txBody>
+                    <a:bodyPr wrap="square"/>
+                    <a:lstStyle/>
+                    <a:p>
+                      <a:r>
+                        <a:rPr sz="800" b="0" i="0">
+                          <a:solidFill>
+                            <a:srgbClr val="16213A"/>
+                          </a:solidFill>
+                          <a:latin typeface="Arial"/>
+                          <a:ea typeface="Malgun Gothic"/>
+                          <a:cs typeface="Malgun Gothic"/>
+                        </a:rPr>
+                        <a:t>Diffusion Planner, GoalFlow, NavDP, CaRL, Alpamayo, MolmoAct, VAMOS, FPO</a:t>
+                      </a:r>
+                    </a:p>
+                  </a:txBody>
+                  <a:tcPr marL="63500" marR="63500" marT="12700" marB="12700">
+                    <a:solidFill>
+                      <a:srgbClr val="F3F0E8"/>
+                    </a:solidFill>
+                  </a:tcPr>
+                </a:tc>
+                <a:tc>
+                  <a:txBody>
+                    <a:bodyPr wrap="square"/>
+                    <a:lstStyle/>
+                    <a:p>
+                      <a:r>
+                        <a:rPr sz="800" b="0" i="0">
+                          <a:solidFill>
+                            <a:srgbClr val="16213A"/>
+                          </a:solidFill>
+                          <a:latin typeface="Arial"/>
+                          <a:ea typeface="Malgun Gothic"/>
+                          <a:cs typeface="Malgun Gothic"/>
+                        </a:rPr>
+                        <a:t>CVaR-BF, DRA-MPPI</a:t>
+                      </a:r>
+                    </a:p>
+                  </a:txBody>
+                  <a:tcPr marL="63500" marR="63500" marT="12700" marB="12700">
+                    <a:solidFill>
+                      <a:srgbClr val="F3F0E8"/>
+                    </a:solidFill>
+                  </a:tcPr>
+                </a:tc>
+                <a:tc>
+                  <a:txBody>
+                    <a:bodyPr wrap="square"/>
+                    <a:lstStyle/>
+                    <a:p>
+                      <a:r>
+                        <a:rPr sz="800" b="0" i="0">
+                          <a:solidFill>
+                            <a:srgbClr val="16213A"/>
+                          </a:solidFill>
+                          <a:latin typeface="Arial"/>
+                          <a:ea typeface="Malgun Gothic"/>
+                          <a:cs typeface="Malgun Gothic"/>
+                        </a:rPr>
+                        <a:t>Isaac Lab, MuJoCo Playground, URBAN-SIM, UrbanVerse, COMPASS, Cosmos</a:t>
+                      </a:r>
+                    </a:p>
+                  </a:txBody>
+                  <a:tcPr marL="63500" marR="63500" marT="12700" marB="12700">
+                    <a:solidFill>
+                      <a:srgbClr val="F3F0E8"/>
+                    </a:solidFill>
+                  </a:tcPr>
+                </a:tc>
+              </a:tr>
+              <a:tr h="317976">
+                <a:tc>
+                  <a:txBody>
+                    <a:bodyPr wrap="square"/>
+                    <a:lstStyle/>
+                    <a:p>
+                      <a:r>
+                        <a:rPr sz="800" b="0" i="0">
+                          <a:solidFill>
+                            <a:srgbClr val="16213A"/>
+                          </a:solidFill>
+                          <a:latin typeface="Arial"/>
+                          <a:ea typeface="Malgun Gothic"/>
+                          <a:cs typeface="Malgun Gothic"/>
+                        </a:rPr>
                         <a:t>2026</a:t>
                       </a:r>
                     </a:p>
                   </a:txBody>
                   <a:tcPr marL="63500" marR="63500" marT="12700" marB="12700">
                     <a:solidFill>
-                      <a:srgbClr val="F3F0E8"/>
+                      <a:srgbClr val="FFFDF8"/>
                     </a:solidFill>
                   </a:tcPr>
                 </a:tc>
@@ -9339,7 +9437,7 @@
                   </a:txBody>
                   <a:tcPr marL="63500" marR="63500" marT="12700" marB="12700">
                     <a:solidFill>
-                      <a:srgbClr val="F3F0E8"/>
+                      <a:srgbClr val="FFFDF8"/>
                     </a:solidFill>
                   </a:tcPr>
                 </a:tc>
@@ -9363,7 +9461,7 @@
                   </a:txBody>
                   <a:tcPr marL="63500" marR="63500" marT="12700" marB="12700">
                     <a:solidFill>
-                      <a:srgbClr val="F3F0E8"/>
+                      <a:srgbClr val="FFFDF8"/>
                     </a:solidFill>
                   </a:tcPr>
                 </a:tc>
@@ -9387,7 +9485,7 @@
                   </a:txBody>
                   <a:tcPr marL="63500" marR="63500" marT="12700" marB="12700">
                     <a:solidFill>
-                      <a:srgbClr val="F3F0E8"/>
+                      <a:srgbClr val="FFFDF8"/>
                     </a:solidFill>
                   </a:tcPr>
                 </a:tc>
@@ -9411,7 +9509,7 @@
                   </a:txBody>
                   <a:tcPr marL="63500" marR="63500" marT="12700" marB="12700">
                     <a:solidFill>
-                      <a:srgbClr val="F3F0E8"/>
+                      <a:srgbClr val="FFFDF8"/>
                     </a:solidFill>
                   </a:tcPr>
                 </a:tc>

</xml_diff>

<commit_message>
sync docs/ from travplan@f48eb70
</commit_message>
<xml_diff>
--- a/slides/research-overview/research-overview.pptx
+++ b/slides/research-overview/research-overview.pptx
@@ -6700,7 +6700,7 @@
                 <a:ea typeface="Malgun Gothic"/>
                 <a:cs typeface="Malgun Gothic"/>
               </a:rPr>
-              <a:t> 문서마다 첫 탭이 개요(분야 계보, 공개 코드·모델 현황, travplan의 위치)이고, 그 뒤가 주제별 탭이다. 절 번호는 문서를 옮겨도 그대로 둔다(인식 A, Planner B, Controller E와 안전 필터 C, 시뮬레이션 S, 배경 0, 강화학습 R, 딥러닝 L, 참고문헌 D).</a:t>
+              <a:t> 문서마다 첫 탭이 개요(분야 계보, 공개 코드·모델 현황, travplan의 위치)이고, 그 뒤가 주제별 탭이다. 절 번호는 문서를 옮겨도 그대로 둔다(인식 A, Planner B, Controller E와 안전 필터 C, 시뮬레이션 S, 배경 0, 강화학습 R, 딥러닝 L, 모방 I, 참고문헌 D).</a:t>
             </a:r>
           </a:p>
         </p:txBody>
@@ -6715,7 +6715,7 @@
         </p:nvGraphicFramePr>
         <p:xfrm>
           <a:off x="609600" y="4618633"/>
-          <a:ext cx="10966451" cy="1271904"/>
+          <a:ext cx="10966449" cy="1271904"/>
         </p:xfrm>
         <a:graphic>
           <a:graphicData uri="http://schemas.openxmlformats.org/drawingml/2006/table">
@@ -6724,10 +6724,10 @@
                 <a:tableStyleId>{5C22544A-7EE6-4342-B048-85BDC9FD1C3A}</a:tableStyleId>
               </a:tblPr>
               <a:tblGrid>
-                <a:gridCol w="890191"/>
-                <a:gridCol w="4991100"/>
-                <a:gridCol w="2763441"/>
-                <a:gridCol w="2321719"/>
+                <a:gridCol w="841970"/>
+                <a:gridCol w="4119860"/>
+                <a:gridCol w="3766145"/>
+                <a:gridCol w="2238474"/>
               </a:tblGrid>
               <a:tr h="197088">
                 <a:tc>
@@ -7316,7 +7316,7 @@
         </p:nvGraphicFramePr>
         <p:xfrm>
           <a:off x="609600" y="1244600"/>
-          <a:ext cx="10966451" cy="1907856"/>
+          <a:ext cx="10966449" cy="2467608"/>
         </p:xfrm>
         <a:graphic>
           <a:graphicData uri="http://schemas.openxmlformats.org/drawingml/2006/table">
@@ -7325,10 +7325,10 @@
                 <a:tableStyleId>{5C22544A-7EE6-4342-B048-85BDC9FD1C3A}</a:tableStyleId>
               </a:tblPr>
               <a:tblGrid>
-                <a:gridCol w="890191"/>
-                <a:gridCol w="4991100"/>
-                <a:gridCol w="2763441"/>
-                <a:gridCol w="2321719"/>
+                <a:gridCol w="841970"/>
+                <a:gridCol w="4119860"/>
+                <a:gridCol w="3766145"/>
+                <a:gridCol w="2238474"/>
               </a:tblGrid>
               <a:tr h="197088">
                 <a:tc>
@@ -7526,7 +7526,7 @@
                   </a:tcPr>
                 </a:tc>
               </a:tr>
-              <a:tr h="197088">
+              <a:tr h="317976">
                 <a:tc>
                   <a:txBody>
                     <a:bodyPr wrap="square"/>
@@ -7820,6 +7820,104 @@
                   </a:tcPr>
                 </a:tc>
               </a:tr>
+              <a:tr h="438864">
+                <a:tc>
+                  <a:txBody>
+                    <a:bodyPr wrap="square"/>
+                    <a:lstStyle/>
+                    <a:p>
+                      <a:r>
+                        <a:rPr sz="800" b="0" i="0">
+                          <a:solidFill>
+                            <a:srgbClr val="16213A"/>
+                          </a:solidFill>
+                          <a:latin typeface="Arial"/>
+                          <a:ea typeface="Malgun Gothic"/>
+                          <a:cs typeface="Malgun Gothic"/>
+                        </a:rPr>
+                        <a:t>모방 (§I)</a:t>
+                      </a:r>
+                    </a:p>
+                  </a:txBody>
+                  <a:tcPr marL="63500" marR="63500" marT="12700" marB="12700">
+                    <a:solidFill>
+                      <a:srgbClr val="FFFDF8"/>
+                    </a:solidFill>
+                  </a:tcPr>
+                </a:tc>
+                <a:tc>
+                  <a:txBody>
+                    <a:bodyPr wrap="square"/>
+                    <a:lstStyle/>
+                    <a:p>
+                      <a:r>
+                        <a:rPr sz="800" b="0" i="0">
+                          <a:solidFill>
+                            <a:srgbClr val="16213A"/>
+                          </a:solidFill>
+                          <a:latin typeface="Arial"/>
+                          <a:ea typeface="Malgun Gothic"/>
+                          <a:cs typeface="Malgun Gothic"/>
+                        </a:rPr>
+                        <a:t>개요(I.0), 데이터·리타기팅(I.1–I.6), 동작 추종(I.7–I.9), 범용 추종기(I.10–I.12), 위 층(I.13), travplan에서(I.14)</a:t>
+                      </a:r>
+                    </a:p>
+                  </a:txBody>
+                  <a:tcPr marL="63500" marR="63500" marT="12700" marB="12700">
+                    <a:solidFill>
+                      <a:srgbClr val="FFFDF8"/>
+                    </a:solidFill>
+                  </a:tcPr>
+                </a:tc>
+                <a:tc>
+                  <a:txBody>
+                    <a:bodyPr wrap="square"/>
+                    <a:lstStyle/>
+                    <a:p>
+                      <a:r>
+                        <a:rPr sz="800" b="0" i="0">
+                          <a:solidFill>
+                            <a:srgbClr val="16213A"/>
+                          </a:solidFill>
+                          <a:latin typeface="Arial"/>
+                          <a:ea typeface="Malgun Gothic"/>
+                          <a:cs typeface="Malgun Gothic"/>
+                        </a:rPr>
+                        <a:t>사람 동작 데이터와 라이선스, 리타기팅(로봇 쪽 고전, GMR·OmniRetarget), 동작 추종(SAMCON·DeepMimic에서 BeyondMimic까지의 계보), 범용 추종기(SONIC, SuperMimic)와 2026년 후속, 공개 코드. 장난감 문제를 풀어 그린 그림</a:t>
+                      </a:r>
+                    </a:p>
+                  </a:txBody>
+                  <a:tcPr marL="63500" marR="63500" marT="12700" marB="12700">
+                    <a:solidFill>
+                      <a:srgbClr val="FFFDF8"/>
+                    </a:solidFill>
+                  </a:tcPr>
+                </a:tc>
+                <a:tc>
+                  <a:txBody>
+                    <a:bodyPr wrap="square"/>
+                    <a:lstStyle/>
+                    <a:p>
+                      <a:r>
+                        <a:rPr sz="800" b="0" i="0">
+                          <a:solidFill>
+                            <a:srgbClr val="16213A"/>
+                          </a:solidFill>
+                          <a:latin typeface="Arial"/>
+                          <a:ea typeface="Malgun Gothic"/>
+                          <a:cs typeface="Malgun Gothic"/>
+                        </a:rPr>
+                        <a:t>학습 절차(적응 표집, 교사–학생, world model을 통한 정책 기울기), Planner·Controller 분리, Playground 휴머노이드</a:t>
+                      </a:r>
+                    </a:p>
+                  </a:txBody>
+                  <a:tcPr marL="63500" marR="63500" marT="12700" marB="12700">
+                    <a:solidFill>
+                      <a:srgbClr val="FFFDF8"/>
+                    </a:solidFill>
+                  </a:tcPr>
+                </a:tc>
+              </a:tr>
               <a:tr h="317976">
                 <a:tc>
                   <a:txBody>
@@ -7841,7 +7939,7 @@
                   </a:txBody>
                   <a:tcPr marL="63500" marR="63500" marT="12700" marB="12700">
                     <a:solidFill>
-                      <a:srgbClr val="FFFDF8"/>
+                      <a:srgbClr val="F3F0E8"/>
                     </a:solidFill>
                   </a:tcPr>
                 </a:tc>
@@ -7859,13 +7957,13 @@
                           <a:ea typeface="Malgun Gothic"/>
                           <a:cs typeface="Malgun Gothic"/>
                         </a:rPr>
-                        <a:t>인식(D.1–D.3b), Planner(D.0–D.5b), Controller·안전(D.6–D.7b), 강화학습(D.14), 연구 그룹(D.13), 로코모션·데이터·산업(D.8–D.12)</a:t>
-                      </a:r>
-                    </a:p>
-                  </a:txBody>
-                  <a:tcPr marL="63500" marR="63500" marT="12700" marB="12700">
-                    <a:solidFill>
-                      <a:srgbClr val="FFFDF8"/>
+                        <a:t>인식(D.1–D.3b), Planner(D.0–D.5b), Controller·안전(D.6–D.7b), 강화학습(D.14), 딥러닝(D.15), 모방(D.16), 연구 그룹(D.13), 로코모션·데이터·산업(D.8–D.12)</a:t>
+                      </a:r>
+                    </a:p>
+                  </a:txBody>
+                  <a:tcPr marL="63500" marR="63500" marT="12700" marB="12700">
+                    <a:solidFill>
+                      <a:srgbClr val="F3F0E8"/>
                     </a:solidFill>
                   </a:tcPr>
                 </a:tc>
@@ -7889,7 +7987,7 @@
                   </a:txBody>
                   <a:tcPr marL="63500" marR="63500" marT="12700" marB="12700">
                     <a:solidFill>
-                      <a:srgbClr val="FFFDF8"/>
+                      <a:srgbClr val="F3F0E8"/>
                     </a:solidFill>
                   </a:tcPr>
                 </a:tc>
@@ -7913,7 +8011,7 @@
                   </a:txBody>
                   <a:tcPr marL="63500" marR="63500" marT="12700" marB="12700">
                     <a:solidFill>
-                      <a:srgbClr val="FFFDF8"/>
+                      <a:srgbClr val="F3F0E8"/>
                     </a:solidFill>
                   </a:tcPr>
                 </a:tc>
@@ -7930,7 +8028,7 @@
         </p:nvSpPr>
         <p:spPr>
           <a:xfrm>
-            <a:off x="609600" y="3724672"/>
+            <a:off x="609600" y="4424362"/>
             <a:ext cx="10972800" cy="432991"/>
           </a:xfrm>
           <a:prstGeom prst="rect">
@@ -7979,8 +8077,8 @@
           <p:nvPr/>
         </p:nvGraphicFramePr>
         <p:xfrm>
-          <a:off x="609600" y="4246562"/>
-          <a:ext cx="10966449" cy="1468992"/>
+          <a:off x="609600" y="4946253"/>
+          <a:ext cx="10966449" cy="833040"/>
         </p:xfrm>
         <a:graphic>
           <a:graphicData uri="http://schemas.openxmlformats.org/drawingml/2006/table">
@@ -8351,250 +8449,6 @@
                           <a:cs typeface="Malgun Gothic"/>
                         </a:rPr>
                         <a:t>—</a:t>
-                      </a:r>
-                    </a:p>
-                  </a:txBody>
-                  <a:tcPr marL="63500" marR="63500" marT="12700" marB="12700">
-                    <a:solidFill>
-                      <a:srgbClr val="F3F0E8"/>
-                    </a:solidFill>
-                  </a:tcPr>
-                </a:tc>
-              </a:tr>
-              <a:tr h="317976">
-                <a:tc>
-                  <a:txBody>
-                    <a:bodyPr wrap="square"/>
-                    <a:lstStyle/>
-                    <a:p>
-                      <a:r>
-                        <a:rPr sz="800" b="0" i="0">
-                          <a:solidFill>
-                            <a:srgbClr val="16213A"/>
-                          </a:solidFill>
-                          <a:latin typeface="Arial"/>
-                          <a:ea typeface="Malgun Gothic"/>
-                          <a:cs typeface="Malgun Gothic"/>
-                        </a:rPr>
-                        <a:t>2015–2018</a:t>
-                      </a:r>
-                    </a:p>
-                  </a:txBody>
-                  <a:tcPr marL="63500" marR="63500" marT="12700" marB="12700">
-                    <a:solidFill>
-                      <a:srgbClr val="FFFDF8"/>
-                    </a:solidFill>
-                  </a:tcPr>
-                </a:tc>
-                <a:tc>
-                  <a:txBody>
-                    <a:bodyPr wrap="square"/>
-                    <a:lstStyle/>
-                    <a:p>
-                      <a:r>
-                        <a:rPr sz="800" b="0" i="0">
-                          <a:solidFill>
-                            <a:srgbClr val="16213A"/>
-                          </a:solidFill>
-                          <a:latin typeface="Arial"/>
-                          <a:ea typeface="Malgun Gothic"/>
-                          <a:cs typeface="Malgun Gothic"/>
-                        </a:rPr>
-                        <a:t>Social GAN</a:t>
-                      </a:r>
-                    </a:p>
-                  </a:txBody>
-                  <a:tcPr marL="63500" marR="63500" marT="12700" marB="12700">
-                    <a:solidFill>
-                      <a:srgbClr val="FFFDF8"/>
-                    </a:solidFill>
-                  </a:tcPr>
-                </a:tc>
-                <a:tc>
-                  <a:txBody>
-                    <a:bodyPr wrap="square"/>
-                    <a:lstStyle/>
-                    <a:p>
-                      <a:r>
-                        <a:rPr sz="800" b="0" i="0">
-                          <a:solidFill>
-                            <a:srgbClr val="16213A"/>
-                          </a:solidFill>
-                          <a:latin typeface="Arial"/>
-                          <a:ea typeface="Malgun Gothic"/>
-                          <a:cs typeface="Malgun Gothic"/>
-                        </a:rPr>
-                        <a:t>Apollo EM planner</a:t>
-                      </a:r>
-                    </a:p>
-                  </a:txBody>
-                  <a:tcPr marL="63500" marR="63500" marT="12700" marB="12700">
-                    <a:solidFill>
-                      <a:srgbClr val="FFFDF8"/>
-                    </a:solidFill>
-                  </a:tcPr>
-                </a:tc>
-                <a:tc>
-                  <a:txBody>
-                    <a:bodyPr wrap="square"/>
-                    <a:lstStyle/>
-                    <a:p>
-                      <a:r>
-                        <a:rPr sz="800" b="0" i="0">
-                          <a:solidFill>
-                            <a:srgbClr val="16213A"/>
-                          </a:solidFill>
-                          <a:latin typeface="Arial"/>
-                          <a:ea typeface="Malgun Gothic"/>
-                          <a:cs typeface="Malgun Gothic"/>
-                        </a:rPr>
-                        <a:t>MPPI, 정보이론적 MPC, CBF-QP, HJ 도달 가능성, PETS, 예측 안전 필터</a:t>
-                      </a:r>
-                    </a:p>
-                  </a:txBody>
-                  <a:tcPr marL="63500" marR="63500" marT="12700" marB="12700">
-                    <a:solidFill>
-                      <a:srgbClr val="FFFDF8"/>
-                    </a:solidFill>
-                  </a:tcPr>
-                </a:tc>
-                <a:tc>
-                  <a:txBody>
-                    <a:bodyPr wrap="square"/>
-                    <a:lstStyle/>
-                    <a:p>
-                      <a:r>
-                        <a:rPr sz="800" b="0" i="0">
-                          <a:solidFill>
-                            <a:srgbClr val="16213A"/>
-                          </a:solidFill>
-                          <a:latin typeface="Arial"/>
-                          <a:ea typeface="Malgun Gothic"/>
-                          <a:cs typeface="Malgun Gothic"/>
-                        </a:rPr>
-                        <a:t>Sorour 등, Domain Randomization, Dynamics Randomization</a:t>
-                      </a:r>
-                    </a:p>
-                  </a:txBody>
-                  <a:tcPr marL="63500" marR="63500" marT="12700" marB="12700">
-                    <a:solidFill>
-                      <a:srgbClr val="FFFDF8"/>
-                    </a:solidFill>
-                  </a:tcPr>
-                </a:tc>
-              </a:tr>
-              <a:tr h="317976">
-                <a:tc>
-                  <a:txBody>
-                    <a:bodyPr wrap="square"/>
-                    <a:lstStyle/>
-                    <a:p>
-                      <a:r>
-                        <a:rPr sz="800" b="0" i="0">
-                          <a:solidFill>
-                            <a:srgbClr val="16213A"/>
-                          </a:solidFill>
-                          <a:latin typeface="Arial"/>
-                          <a:ea typeface="Malgun Gothic"/>
-                          <a:cs typeface="Malgun Gothic"/>
-                        </a:rPr>
-                        <a:t>2019–2020</a:t>
-                      </a:r>
-                    </a:p>
-                  </a:txBody>
-                  <a:tcPr marL="63500" marR="63500" marT="12700" marB="12700">
-                    <a:solidFill>
-                      <a:srgbClr val="F3F0E8"/>
-                    </a:solidFill>
-                  </a:tcPr>
-                </a:tc>
-                <a:tc>
-                  <a:txBody>
-                    <a:bodyPr wrap="square"/>
-                    <a:lstStyle/>
-                    <a:p>
-                      <a:r>
-                        <a:rPr sz="800" b="0" i="0">
-                          <a:solidFill>
-                            <a:srgbClr val="16213A"/>
-                          </a:solidFill>
-                          <a:latin typeface="Arial"/>
-                          <a:ea typeface="Malgun Gothic"/>
-                          <a:cs typeface="Malgun Gothic"/>
-                        </a:rPr>
-                        <a:t>Lift-Splat-Shoot, RELLIS-3D, BADGR, 등속 모델, Trajectron++</a:t>
-                      </a:r>
-                    </a:p>
-                  </a:txBody>
-                  <a:tcPr marL="63500" marR="63500" marT="12700" marB="12700">
-                    <a:solidFill>
-                      <a:srgbClr val="F3F0E8"/>
-                    </a:solidFill>
-                  </a:tcPr>
-                </a:tc>
-                <a:tc>
-                  <a:txBody>
-                    <a:bodyPr wrap="square"/>
-                    <a:lstStyle/>
-                    <a:p>
-                      <a:r>
-                        <a:rPr sz="800" b="0" i="0">
-                          <a:solidFill>
-                            <a:srgbClr val="16213A"/>
-                          </a:solidFill>
-                          <a:latin typeface="Arial"/>
-                          <a:ea typeface="Malgun Gothic"/>
-                          <a:cs typeface="Malgun Gothic"/>
-                        </a:rPr>
-                        <a:t>Nav2</a:t>
-                      </a:r>
-                    </a:p>
-                  </a:txBody>
-                  <a:tcPr marL="63500" marR="63500" marT="12700" marB="12700">
-                    <a:solidFill>
-                      <a:srgbClr val="F3F0E8"/>
-                    </a:solidFill>
-                  </a:tcPr>
-                </a:tc>
-                <a:tc>
-                  <a:txBody>
-                    <a:bodyPr wrap="square"/>
-                    <a:lstStyle/>
-                    <a:p>
-                      <a:r>
-                        <a:rPr sz="800" b="0" i="0">
-                          <a:solidFill>
-                            <a:srgbClr val="16213A"/>
-                          </a:solidFill>
-                          <a:latin typeface="Arial"/>
-                          <a:ea typeface="Malgun Gothic"/>
-                          <a:cs typeface="Malgun Gothic"/>
-                        </a:rPr>
-                        <a:t>CBF 튜토리얼, 이산 CBF + MPC</a:t>
-                      </a:r>
-                    </a:p>
-                  </a:txBody>
-                  <a:tcPr marL="63500" marR="63500" marT="12700" marB="12700">
-                    <a:solidFill>
-                      <a:srgbClr val="F3F0E8"/>
-                    </a:solidFill>
-                  </a:tcPr>
-                </a:tc>
-                <a:tc>
-                  <a:txBody>
-                    <a:bodyPr wrap="square"/>
-                    <a:lstStyle/>
-                    <a:p>
-                      <a:r>
-                        <a:rPr sz="800" b="0" i="0">
-                          <a:solidFill>
-                            <a:srgbClr val="16213A"/>
-                          </a:solidFill>
-                          <a:latin typeface="Arial"/>
-                          <a:ea typeface="Malgun Gothic"/>
-                          <a:cs typeface="Malgun Gothic"/>
-                        </a:rPr>
-                        <a:t>Actuator net, ADR, Sim2Real Predictivity</a:t>
                       </a:r>
                     </a:p>
                   </a:txBody>
@@ -8767,7 +8621,7 @@
         </p:nvGraphicFramePr>
         <p:xfrm>
           <a:off x="609600" y="1244600"/>
-          <a:ext cx="10966449" cy="1786968"/>
+          <a:ext cx="10966449" cy="2422920"/>
         </p:xfrm>
         <a:graphic>
           <a:graphicData uri="http://schemas.openxmlformats.org/drawingml/2006/table">
@@ -8900,6 +8754,250 @@
                   <a:tcPr marL="63500" marR="63500" marT="12700" marB="12700">
                     <a:solidFill>
                       <a:srgbClr val="16213A"/>
+                    </a:solidFill>
+                  </a:tcPr>
+                </a:tc>
+              </a:tr>
+              <a:tr h="317976">
+                <a:tc>
+                  <a:txBody>
+                    <a:bodyPr wrap="square"/>
+                    <a:lstStyle/>
+                    <a:p>
+                      <a:r>
+                        <a:rPr sz="800" b="0" i="0">
+                          <a:solidFill>
+                            <a:srgbClr val="16213A"/>
+                          </a:solidFill>
+                          <a:latin typeface="Arial"/>
+                          <a:ea typeface="Malgun Gothic"/>
+                          <a:cs typeface="Malgun Gothic"/>
+                        </a:rPr>
+                        <a:t>2015–2018</a:t>
+                      </a:r>
+                    </a:p>
+                  </a:txBody>
+                  <a:tcPr marL="63500" marR="63500" marT="12700" marB="12700">
+                    <a:solidFill>
+                      <a:srgbClr val="FFFDF8"/>
+                    </a:solidFill>
+                  </a:tcPr>
+                </a:tc>
+                <a:tc>
+                  <a:txBody>
+                    <a:bodyPr wrap="square"/>
+                    <a:lstStyle/>
+                    <a:p>
+                      <a:r>
+                        <a:rPr sz="800" b="0" i="0">
+                          <a:solidFill>
+                            <a:srgbClr val="16213A"/>
+                          </a:solidFill>
+                          <a:latin typeface="Arial"/>
+                          <a:ea typeface="Malgun Gothic"/>
+                          <a:cs typeface="Malgun Gothic"/>
+                        </a:rPr>
+                        <a:t>Social GAN</a:t>
+                      </a:r>
+                    </a:p>
+                  </a:txBody>
+                  <a:tcPr marL="63500" marR="63500" marT="12700" marB="12700">
+                    <a:solidFill>
+                      <a:srgbClr val="FFFDF8"/>
+                    </a:solidFill>
+                  </a:tcPr>
+                </a:tc>
+                <a:tc>
+                  <a:txBody>
+                    <a:bodyPr wrap="square"/>
+                    <a:lstStyle/>
+                    <a:p>
+                      <a:r>
+                        <a:rPr sz="800" b="0" i="0">
+                          <a:solidFill>
+                            <a:srgbClr val="16213A"/>
+                          </a:solidFill>
+                          <a:latin typeface="Arial"/>
+                          <a:ea typeface="Malgun Gothic"/>
+                          <a:cs typeface="Malgun Gothic"/>
+                        </a:rPr>
+                        <a:t>Apollo EM planner</a:t>
+                      </a:r>
+                    </a:p>
+                  </a:txBody>
+                  <a:tcPr marL="63500" marR="63500" marT="12700" marB="12700">
+                    <a:solidFill>
+                      <a:srgbClr val="FFFDF8"/>
+                    </a:solidFill>
+                  </a:tcPr>
+                </a:tc>
+                <a:tc>
+                  <a:txBody>
+                    <a:bodyPr wrap="square"/>
+                    <a:lstStyle/>
+                    <a:p>
+                      <a:r>
+                        <a:rPr sz="800" b="0" i="0">
+                          <a:solidFill>
+                            <a:srgbClr val="16213A"/>
+                          </a:solidFill>
+                          <a:latin typeface="Arial"/>
+                          <a:ea typeface="Malgun Gothic"/>
+                          <a:cs typeface="Malgun Gothic"/>
+                        </a:rPr>
+                        <a:t>MPPI, 정보이론적 MPC, CBF-QP, HJ 도달 가능성, PETS, 예측 안전 필터</a:t>
+                      </a:r>
+                    </a:p>
+                  </a:txBody>
+                  <a:tcPr marL="63500" marR="63500" marT="12700" marB="12700">
+                    <a:solidFill>
+                      <a:srgbClr val="FFFDF8"/>
+                    </a:solidFill>
+                  </a:tcPr>
+                </a:tc>
+                <a:tc>
+                  <a:txBody>
+                    <a:bodyPr wrap="square"/>
+                    <a:lstStyle/>
+                    <a:p>
+                      <a:r>
+                        <a:rPr sz="800" b="0" i="0">
+                          <a:solidFill>
+                            <a:srgbClr val="16213A"/>
+                          </a:solidFill>
+                          <a:latin typeface="Arial"/>
+                          <a:ea typeface="Malgun Gothic"/>
+                          <a:cs typeface="Malgun Gothic"/>
+                        </a:rPr>
+                        <a:t>Sorour 등, Domain Randomization, Dynamics Randomization</a:t>
+                      </a:r>
+                    </a:p>
+                  </a:txBody>
+                  <a:tcPr marL="63500" marR="63500" marT="12700" marB="12700">
+                    <a:solidFill>
+                      <a:srgbClr val="FFFDF8"/>
+                    </a:solidFill>
+                  </a:tcPr>
+                </a:tc>
+              </a:tr>
+              <a:tr h="317976">
+                <a:tc>
+                  <a:txBody>
+                    <a:bodyPr wrap="square"/>
+                    <a:lstStyle/>
+                    <a:p>
+                      <a:r>
+                        <a:rPr sz="800" b="0" i="0">
+                          <a:solidFill>
+                            <a:srgbClr val="16213A"/>
+                          </a:solidFill>
+                          <a:latin typeface="Arial"/>
+                          <a:ea typeface="Malgun Gothic"/>
+                          <a:cs typeface="Malgun Gothic"/>
+                        </a:rPr>
+                        <a:t>2019–2020</a:t>
+                      </a:r>
+                    </a:p>
+                  </a:txBody>
+                  <a:tcPr marL="63500" marR="63500" marT="12700" marB="12700">
+                    <a:solidFill>
+                      <a:srgbClr val="F3F0E8"/>
+                    </a:solidFill>
+                  </a:tcPr>
+                </a:tc>
+                <a:tc>
+                  <a:txBody>
+                    <a:bodyPr wrap="square"/>
+                    <a:lstStyle/>
+                    <a:p>
+                      <a:r>
+                        <a:rPr sz="800" b="0" i="0">
+                          <a:solidFill>
+                            <a:srgbClr val="16213A"/>
+                          </a:solidFill>
+                          <a:latin typeface="Arial"/>
+                          <a:ea typeface="Malgun Gothic"/>
+                          <a:cs typeface="Malgun Gothic"/>
+                        </a:rPr>
+                        <a:t>Lift-Splat-Shoot, RELLIS-3D, BADGR, 등속 모델, Trajectron++</a:t>
+                      </a:r>
+                    </a:p>
+                  </a:txBody>
+                  <a:tcPr marL="63500" marR="63500" marT="12700" marB="12700">
+                    <a:solidFill>
+                      <a:srgbClr val="F3F0E8"/>
+                    </a:solidFill>
+                  </a:tcPr>
+                </a:tc>
+                <a:tc>
+                  <a:txBody>
+                    <a:bodyPr wrap="square"/>
+                    <a:lstStyle/>
+                    <a:p>
+                      <a:r>
+                        <a:rPr sz="800" b="0" i="0">
+                          <a:solidFill>
+                            <a:srgbClr val="16213A"/>
+                          </a:solidFill>
+                          <a:latin typeface="Arial"/>
+                          <a:ea typeface="Malgun Gothic"/>
+                          <a:cs typeface="Malgun Gothic"/>
+                        </a:rPr>
+                        <a:t>Nav2</a:t>
+                      </a:r>
+                    </a:p>
+                  </a:txBody>
+                  <a:tcPr marL="63500" marR="63500" marT="12700" marB="12700">
+                    <a:solidFill>
+                      <a:srgbClr val="F3F0E8"/>
+                    </a:solidFill>
+                  </a:tcPr>
+                </a:tc>
+                <a:tc>
+                  <a:txBody>
+                    <a:bodyPr wrap="square"/>
+                    <a:lstStyle/>
+                    <a:p>
+                      <a:r>
+                        <a:rPr sz="800" b="0" i="0">
+                          <a:solidFill>
+                            <a:srgbClr val="16213A"/>
+                          </a:solidFill>
+                          <a:latin typeface="Arial"/>
+                          <a:ea typeface="Malgun Gothic"/>
+                          <a:cs typeface="Malgun Gothic"/>
+                        </a:rPr>
+                        <a:t>CBF 튜토리얼, 이산 CBF + MPC</a:t>
+                      </a:r>
+                    </a:p>
+                  </a:txBody>
+                  <a:tcPr marL="63500" marR="63500" marT="12700" marB="12700">
+                    <a:solidFill>
+                      <a:srgbClr val="F3F0E8"/>
+                    </a:solidFill>
+                  </a:tcPr>
+                </a:tc>
+                <a:tc>
+                  <a:txBody>
+                    <a:bodyPr wrap="square"/>
+                    <a:lstStyle/>
+                    <a:p>
+                      <a:r>
+                        <a:rPr sz="800" b="0" i="0">
+                          <a:solidFill>
+                            <a:srgbClr val="16213A"/>
+                          </a:solidFill>
+                          <a:latin typeface="Arial"/>
+                          <a:ea typeface="Malgun Gothic"/>
+                          <a:cs typeface="Malgun Gothic"/>
+                        </a:rPr>
+                        <a:t>Actuator net, ADR, Sim2Real Predictivity</a:t>
+                      </a:r>
+                    </a:p>
+                  </a:txBody>
+                  <a:tcPr marL="63500" marR="63500" marT="12700" marB="12700">
+                    <a:solidFill>
+                      <a:srgbClr val="F3F0E8"/>
                     </a:solidFill>
                   </a:tcPr>
                 </a:tc>

</xml_diff>

<commit_message>
sync docs/ from travplan@2061885
</commit_message>
<xml_diff>
--- a/slides/research-overview/research-overview.pptx
+++ b/slides/research-overview/research-overview.pptx
@@ -6715,7 +6715,7 @@
         </p:nvGraphicFramePr>
         <p:xfrm>
           <a:off x="609600" y="4618633"/>
-          <a:ext cx="10966449" cy="1271904"/>
+          <a:ext cx="10966450" cy="1195704"/>
         </p:xfrm>
         <a:graphic>
           <a:graphicData uri="http://schemas.openxmlformats.org/drawingml/2006/table">
@@ -6724,10 +6724,10 @@
                 <a:tableStyleId>{5C22544A-7EE6-4342-B048-85BDC9FD1C3A}</a:tableStyleId>
               </a:tblPr>
               <a:tblGrid>
-                <a:gridCol w="841970"/>
-                <a:gridCol w="4119860"/>
-                <a:gridCol w="3766145"/>
-                <a:gridCol w="2238474"/>
+                <a:gridCol w="805755"/>
+                <a:gridCol w="4978400"/>
+                <a:gridCol w="3204766"/>
+                <a:gridCol w="1977529"/>
               </a:tblGrid>
               <a:tr h="197088">
                 <a:tc>
@@ -6827,7 +6827,7 @@
                   </a:tcPr>
                 </a:tc>
               </a:tr>
-              <a:tr h="317976">
+              <a:tr h="438864">
                 <a:tc>
                   <a:txBody>
                     <a:bodyPr wrap="square"/>
@@ -6925,7 +6925,7 @@
                   </a:tcPr>
                 </a:tc>
               </a:tr>
-              <a:tr h="438864">
+              <a:tr h="559752">
                 <a:tc>
                   <a:txBody>
                     <a:bodyPr wrap="square"/>
@@ -6997,7 +6997,29 @@
                           <a:ea typeface="Malgun Gothic"/>
                           <a:cs typeface="Malgun Gothic"/>
                         </a:rPr>
-                        <a:t> — 자율주행 자동차(B.12.1, B.11, B.13), 다리·바퀴 로봇과 계보(B.12, B.14, B.16)</a:t>
+                        <a:t> — 자율주행 자동차(B.12.1, B.11, B.13), 로봇별 공개 스택(B.12), ETH RSL 계보(B.14), NVIDIA·DeepMind·취리히·RAI(B.16, B.16.1–B.16.4), 다른 연구실·휴머노이드 주행(B.16.5–B.16.8). </a:t>
+                      </a:r>
+                      <a:r>
+                        <a:rPr sz="800" b="1" i="0">
+                          <a:solidFill>
+                            <a:srgbClr val="16213A"/>
+                          </a:solidFill>
+                          <a:latin typeface="Arial"/>
+                          <a:ea typeface="Malgun Gothic"/>
+                          <a:cs typeface="Malgun Gothic"/>
+                        </a:rPr>
+                        <a:t>종합</a:t>
+                      </a:r>
+                      <a:r>
+                        <a:rPr sz="800" b="0" i="0">
+                          <a:solidFill>
+                            <a:srgbClr val="16213A"/>
+                          </a:solidFill>
+                          <a:latin typeface="Arial"/>
+                          <a:ea typeface="Malgun Gothic"/>
+                          <a:cs typeface="Malgun Gothic"/>
+                        </a:rPr>
+                        <a:t> — 분야별 지형(B.18), 최근 연구 비교(B.17)</a:t>
                       </a:r>
                     </a:p>
                   </a:txBody>
@@ -7052,104 +7074,6 @@
                   <a:tcPr marL="63500" marR="63500" marT="12700" marB="12700">
                     <a:solidFill>
                       <a:srgbClr val="F3F0E8"/>
-                    </a:solidFill>
-                  </a:tcPr>
-                </a:tc>
-              </a:tr>
-              <a:tr h="317976">
-                <a:tc>
-                  <a:txBody>
-                    <a:bodyPr wrap="square"/>
-                    <a:lstStyle/>
-                    <a:p>
-                      <a:r>
-                        <a:rPr sz="800" b="0" i="0">
-                          <a:solidFill>
-                            <a:srgbClr val="16213A"/>
-                          </a:solidFill>
-                          <a:latin typeface="Arial"/>
-                          <a:ea typeface="Malgun Gothic"/>
-                          <a:cs typeface="Malgun Gothic"/>
-                        </a:rPr>
-                        <a:t>Controller·안전 (§E, §C)</a:t>
-                      </a:r>
-                    </a:p>
-                  </a:txBody>
-                  <a:tcPr marL="63500" marR="63500" marT="12700" marB="12700">
-                    <a:solidFill>
-                      <a:srgbClr val="FFFDF8"/>
-                    </a:solidFill>
-                  </a:tcPr>
-                </a:tc>
-                <a:tc>
-                  <a:txBody>
-                    <a:bodyPr wrap="square"/>
-                    <a:lstStyle/>
-                    <a:p>
-                      <a:r>
-                        <a:rPr sz="800" b="0" i="0">
-                          <a:solidFill>
-                            <a:srgbClr val="16213A"/>
-                          </a:solidFill>
-                          <a:latin typeface="Arial"/>
-                          <a:ea typeface="Malgun Gothic"/>
-                          <a:cs typeface="Malgun Gothic"/>
-                        </a:rPr>
-                        <a:t>MPPI 계열(E.1, B.5), 학습 동역학·적응(E, E.2), 안전 필터(C.1–C.4)</a:t>
-                      </a:r>
-                    </a:p>
-                  </a:txBody>
-                  <a:tcPr marL="63500" marR="63500" marT="12700" marB="12700">
-                    <a:solidFill>
-                      <a:srgbClr val="FFFDF8"/>
-                    </a:solidFill>
-                  </a:tcPr>
-                </a:tc>
-                <a:tc>
-                  <a:txBody>
-                    <a:bodyPr wrap="square"/>
-                    <a:lstStyle/>
-                    <a:p>
-                      <a:r>
-                        <a:rPr sz="800" b="0" i="0">
-                          <a:solidFill>
-                            <a:srgbClr val="16213A"/>
-                          </a:solidFill>
-                          <a:latin typeface="Arial"/>
-                          <a:ea typeface="Malgun Gothic"/>
-                          <a:cs typeface="Malgun Gothic"/>
-                        </a:rPr>
-                        <a:t>궤적 추종과 안전</a:t>
-                      </a:r>
-                    </a:p>
-                  </a:txBody>
-                  <a:tcPr marL="63500" marR="63500" marT="12700" marB="12700">
-                    <a:solidFill>
-                      <a:srgbClr val="FFFDF8"/>
-                    </a:solidFill>
-                  </a:tcPr>
-                </a:tc>
-                <a:tc>
-                  <a:txBody>
-                    <a:bodyPr wrap="square"/>
-                    <a:lstStyle/>
-                    <a:p>
-                      <a:r>
-                        <a:rPr sz="800" b="0" i="0">
-                          <a:solidFill>
-                            <a:srgbClr val="16213A"/>
-                          </a:solidFill>
-                          <a:latin typeface="Arial"/>
-                          <a:ea typeface="Malgun Gothic"/>
-                          <a:cs typeface="Malgun Gothic"/>
-                        </a:rPr>
-                        <a:t>MPPIController(유지보수), 시간가변 비용 레이어, CVaR-BF 후보</a:t>
-                      </a:r>
-                    </a:p>
-                  </a:txBody>
-                  <a:tcPr marL="63500" marR="63500" marT="12700" marB="12700">
-                    <a:solidFill>
-                      <a:srgbClr val="FFFDF8"/>
                     </a:solidFill>
                   </a:tcPr>
                 </a:tc>
@@ -7316,7 +7240,7 @@
         </p:nvGraphicFramePr>
         <p:xfrm>
           <a:off x="609600" y="1244600"/>
-          <a:ext cx="10966449" cy="2467608"/>
+          <a:ext cx="10966450" cy="2785584"/>
         </p:xfrm>
         <a:graphic>
           <a:graphicData uri="http://schemas.openxmlformats.org/drawingml/2006/table">
@@ -7325,10 +7249,10 @@
                 <a:tableStyleId>{5C22544A-7EE6-4342-B048-85BDC9FD1C3A}</a:tableStyleId>
               </a:tblPr>
               <a:tblGrid>
-                <a:gridCol w="841970"/>
-                <a:gridCol w="4119860"/>
-                <a:gridCol w="3766145"/>
-                <a:gridCol w="2238474"/>
+                <a:gridCol w="805755"/>
+                <a:gridCol w="4978400"/>
+                <a:gridCol w="3204766"/>
+                <a:gridCol w="1977529"/>
               </a:tblGrid>
               <a:tr h="197088">
                 <a:tc>
@@ -7443,7 +7367,7 @@
                           <a:ea typeface="Malgun Gothic"/>
                           <a:cs typeface="Malgun Gothic"/>
                         </a:rPr>
-                        <a:t>시뮬레이션 (§S)</a:t>
+                        <a:t>Controller·안전 (§E, §C)</a:t>
                       </a:r>
                     </a:p>
                   </a:txBody>
@@ -7467,7 +7391,7 @@
                           <a:ea typeface="Malgun Gothic"/>
                           <a:cs typeface="Malgun Gothic"/>
                         </a:rPr>
-                        <a:t>물리 엔진(S.1), 보도·도시(S.2), 보행자(S.3), 센서·렌더링(S.4), 지형·바퀴(S.5), sim-to-real(S.6), travplan 권고(S.7)</a:t>
+                        <a:t>MPPI 계열(E.1, B.5), 학습 동역학·적응(E, E.2), 안전 필터(C.1–C.4)</a:t>
                       </a:r>
                     </a:p>
                   </a:txBody>
@@ -7491,7 +7415,7 @@
                           <a:ea typeface="Malgun Gothic"/>
                           <a:cs typeface="Malgun Gothic"/>
                         </a:rPr>
-                        <a:t>검증 환경의 네 층(L0–L3)</a:t>
+                        <a:t>궤적 추종과 안전</a:t>
                       </a:r>
                     </a:p>
                   </a:txBody>
@@ -7515,7 +7439,7 @@
                           <a:ea typeface="Malgun Gothic"/>
                           <a:cs typeface="Malgun Gothic"/>
                         </a:rPr>
-                        <a:t>운동학 시뮬(L0), Isaac Sim(L1)</a:t>
+                        <a:t>MPPIController(유지보수), 시간가변 비용 레이어, CVaR-BF 후보</a:t>
                       </a:r>
                     </a:p>
                   </a:txBody>
@@ -7541,13 +7465,111 @@
                           <a:ea typeface="Malgun Gothic"/>
                           <a:cs typeface="Malgun Gothic"/>
                         </a:rPr>
+                        <a:t>시뮬레이션 (§S)</a:t>
+                      </a:r>
+                    </a:p>
+                  </a:txBody>
+                  <a:tcPr marL="63500" marR="63500" marT="12700" marB="12700">
+                    <a:solidFill>
+                      <a:srgbClr val="F3F0E8"/>
+                    </a:solidFill>
+                  </a:tcPr>
+                </a:tc>
+                <a:tc>
+                  <a:txBody>
+                    <a:bodyPr wrap="square"/>
+                    <a:lstStyle/>
+                    <a:p>
+                      <a:r>
+                        <a:rPr sz="800" b="0" i="0">
+                          <a:solidFill>
+                            <a:srgbClr val="16213A"/>
+                          </a:solidFill>
+                          <a:latin typeface="Arial"/>
+                          <a:ea typeface="Malgun Gothic"/>
+                          <a:cs typeface="Malgun Gothic"/>
+                        </a:rPr>
+                        <a:t>물리 엔진(S.1), 보도·도시(S.2), 보행자(S.3), 센서·렌더링(S.4), 지형·바퀴(S.5), sim-to-real(S.6), travplan 권고(S.7)</a:t>
+                      </a:r>
+                    </a:p>
+                  </a:txBody>
+                  <a:tcPr marL="63500" marR="63500" marT="12700" marB="12700">
+                    <a:solidFill>
+                      <a:srgbClr val="F3F0E8"/>
+                    </a:solidFill>
+                  </a:tcPr>
+                </a:tc>
+                <a:tc>
+                  <a:txBody>
+                    <a:bodyPr wrap="square"/>
+                    <a:lstStyle/>
+                    <a:p>
+                      <a:r>
+                        <a:rPr sz="800" b="0" i="0">
+                          <a:solidFill>
+                            <a:srgbClr val="16213A"/>
+                          </a:solidFill>
+                          <a:latin typeface="Arial"/>
+                          <a:ea typeface="Malgun Gothic"/>
+                          <a:cs typeface="Malgun Gothic"/>
+                        </a:rPr>
+                        <a:t>검증 환경의 네 층(L0–L3)</a:t>
+                      </a:r>
+                    </a:p>
+                  </a:txBody>
+                  <a:tcPr marL="63500" marR="63500" marT="12700" marB="12700">
+                    <a:solidFill>
+                      <a:srgbClr val="F3F0E8"/>
+                    </a:solidFill>
+                  </a:tcPr>
+                </a:tc>
+                <a:tc>
+                  <a:txBody>
+                    <a:bodyPr wrap="square"/>
+                    <a:lstStyle/>
+                    <a:p>
+                      <a:r>
+                        <a:rPr sz="800" b="0" i="0">
+                          <a:solidFill>
+                            <a:srgbClr val="16213A"/>
+                          </a:solidFill>
+                          <a:latin typeface="Arial"/>
+                          <a:ea typeface="Malgun Gothic"/>
+                          <a:cs typeface="Malgun Gothic"/>
+                        </a:rPr>
+                        <a:t>운동학 시뮬(L0), Isaac Sim(L1)</a:t>
+                      </a:r>
+                    </a:p>
+                  </a:txBody>
+                  <a:tcPr marL="63500" marR="63500" marT="12700" marB="12700">
+                    <a:solidFill>
+                      <a:srgbClr val="F3F0E8"/>
+                    </a:solidFill>
+                  </a:tcPr>
+                </a:tc>
+              </a:tr>
+              <a:tr h="197088">
+                <a:tc>
+                  <a:txBody>
+                    <a:bodyPr wrap="square"/>
+                    <a:lstStyle/>
+                    <a:p>
+                      <a:r>
+                        <a:rPr sz="800" b="0" i="0">
+                          <a:solidFill>
+                            <a:srgbClr val="16213A"/>
+                          </a:solidFill>
+                          <a:latin typeface="Arial"/>
+                          <a:ea typeface="Malgun Gothic"/>
+                          <a:cs typeface="Malgun Gothic"/>
+                        </a:rPr>
                         <a:t>배경·수식 (§0)</a:t>
                       </a:r>
                     </a:p>
                   </a:txBody>
                   <a:tcPr marL="63500" marR="63500" marT="12700" marB="12700">
                     <a:solidFill>
-                      <a:srgbClr val="F3F0E8"/>
+                      <a:srgbClr val="FFFDF8"/>
                     </a:solidFill>
                   </a:tcPr>
                 </a:tc>
@@ -7571,7 +7593,7 @@
                   </a:txBody>
                   <a:tcPr marL="63500" marR="63500" marT="12700" marB="12700">
                     <a:solidFill>
-                      <a:srgbClr val="F3F0E8"/>
+                      <a:srgbClr val="FFFDF8"/>
                     </a:solidFill>
                   </a:tcPr>
                 </a:tc>
@@ -7595,7 +7617,7 @@
                   </a:txBody>
                   <a:tcPr marL="63500" marR="63500" marT="12700" marB="12700">
                     <a:solidFill>
-                      <a:srgbClr val="F3F0E8"/>
+                      <a:srgbClr val="FFFDF8"/>
                     </a:solidFill>
                   </a:tcPr>
                 </a:tc>
@@ -7619,7 +7641,7 @@
                   </a:txBody>
                   <a:tcPr marL="63500" marR="63500" marT="12700" marB="12700">
                     <a:solidFill>
-                      <a:srgbClr val="F3F0E8"/>
+                      <a:srgbClr val="FFFDF8"/>
                     </a:solidFill>
                   </a:tcPr>
                 </a:tc>
@@ -7645,7 +7667,7 @@
                   </a:txBody>
                   <a:tcPr marL="63500" marR="63500" marT="12700" marB="12700">
                     <a:solidFill>
-                      <a:srgbClr val="FFFDF8"/>
+                      <a:srgbClr val="F3F0E8"/>
                     </a:solidFill>
                   </a:tcPr>
                 </a:tc>
@@ -7669,7 +7691,7 @@
                   </a:txBody>
                   <a:tcPr marL="63500" marR="63500" marT="12700" marB="12700">
                     <a:solidFill>
-                      <a:srgbClr val="FFFDF8"/>
+                      <a:srgbClr val="F3F0E8"/>
                     </a:solidFill>
                   </a:tcPr>
                 </a:tc>
@@ -7693,7 +7715,7 @@
                   </a:txBody>
                   <a:tcPr marL="63500" marR="63500" marT="12700" marB="12700">
                     <a:solidFill>
-                      <a:srgbClr val="FFFDF8"/>
+                      <a:srgbClr val="F3F0E8"/>
                     </a:solidFill>
                   </a:tcPr>
                 </a:tc>
@@ -7717,7 +7739,7 @@
                   </a:txBody>
                   <a:tcPr marL="63500" marR="63500" marT="12700" marB="12700">
                     <a:solidFill>
-                      <a:srgbClr val="FFFDF8"/>
+                      <a:srgbClr val="F3F0E8"/>
                     </a:solidFill>
                   </a:tcPr>
                 </a:tc>
@@ -7743,6 +7765,104 @@
                   </a:txBody>
                   <a:tcPr marL="63500" marR="63500" marT="12700" marB="12700">
                     <a:solidFill>
+                      <a:srgbClr val="FFFDF8"/>
+                    </a:solidFill>
+                  </a:tcPr>
+                </a:tc>
+                <a:tc>
+                  <a:txBody>
+                    <a:bodyPr wrap="square"/>
+                    <a:lstStyle/>
+                    <a:p>
+                      <a:r>
+                        <a:rPr sz="800" b="0" i="0">
+                          <a:solidFill>
+                            <a:srgbClr val="16213A"/>
+                          </a:solidFill>
+                          <a:latin typeface="Arial"/>
+                          <a:ea typeface="Malgun Gothic"/>
+                          <a:cs typeface="Malgun Gothic"/>
+                        </a:rPr>
+                        <a:t>개요(L.0), 기초(L.1–L.3), 구조(L.4–L.8), 생성 모델(L.9–L.13), 자기지도·규모(L.14–L.18), 멀티모달·로봇(L.19–L.21), travplan에서(L.22)</a:t>
+                      </a:r>
+                    </a:p>
+                  </a:txBody>
+                  <a:tcPr marL="63500" marR="63500" marT="12700" marB="12700">
+                    <a:solidFill>
+                      <a:srgbClr val="FFFDF8"/>
+                    </a:solidFill>
+                  </a:tcPr>
+                </a:tc>
+                <a:tc>
+                  <a:txBody>
+                    <a:bodyPr wrap="square"/>
+                    <a:lstStyle/>
+                    <a:p>
+                      <a:r>
+                        <a:rPr sz="800" b="0" i="0">
+                          <a:solidFill>
+                            <a:srgbClr val="16213A"/>
+                          </a:solidFill>
+                          <a:latin typeface="Arial"/>
+                          <a:ea typeface="Malgun Gothic"/>
+                          <a:cs typeface="Malgun Gothic"/>
+                        </a:rPr>
+                        <a:t>교재 Understanding Deep Learning과 MIT 6.S184·Stanford CS336을 뼈대로 한 딥러닝 개념. 장난감 문제를 실제로 풀어 그린 그림</a:t>
+                      </a:r>
+                    </a:p>
+                  </a:txBody>
+                  <a:tcPr marL="63500" marR="63500" marT="12700" marB="12700">
+                    <a:solidFill>
+                      <a:srgbClr val="FFFDF8"/>
+                    </a:solidFill>
+                  </a:tcPr>
+                </a:tc>
+                <a:tc>
+                  <a:txBody>
+                    <a:bodyPr wrap="square"/>
+                    <a:lstStyle/>
+                    <a:p>
+                      <a:r>
+                        <a:rPr sz="800" b="0" i="0">
+                          <a:solidFill>
+                            <a:srgbClr val="16213A"/>
+                          </a:solidFill>
+                          <a:latin typeface="Arial"/>
+                          <a:ea typeface="Malgun Gothic"/>
+                          <a:cs typeface="Malgun Gothic"/>
+                        </a:rPr>
+                        <a:t>Planner D(flow matching), Joint Planner(DiT식 transformer), TravNet, TinyPolicy의 구조와 학습</a:t>
+                      </a:r>
+                    </a:p>
+                  </a:txBody>
+                  <a:tcPr marL="63500" marR="63500" marT="12700" marB="12700">
+                    <a:solidFill>
+                      <a:srgbClr val="FFFDF8"/>
+                    </a:solidFill>
+                  </a:tcPr>
+                </a:tc>
+              </a:tr>
+              <a:tr h="559752">
+                <a:tc>
+                  <a:txBody>
+                    <a:bodyPr wrap="square"/>
+                    <a:lstStyle/>
+                    <a:p>
+                      <a:r>
+                        <a:rPr sz="800" b="0" i="0">
+                          <a:solidFill>
+                            <a:srgbClr val="16213A"/>
+                          </a:solidFill>
+                          <a:latin typeface="Arial"/>
+                          <a:ea typeface="Malgun Gothic"/>
+                          <a:cs typeface="Malgun Gothic"/>
+                        </a:rPr>
+                        <a:t>모방 (§I)</a:t>
+                      </a:r>
+                    </a:p>
+                  </a:txBody>
+                  <a:tcPr marL="63500" marR="63500" marT="12700" marB="12700">
+                    <a:solidFill>
                       <a:srgbClr val="F3F0E8"/>
                     </a:solidFill>
                   </a:tcPr>
@@ -7761,7 +7881,7 @@
                           <a:ea typeface="Malgun Gothic"/>
                           <a:cs typeface="Malgun Gothic"/>
                         </a:rPr>
-                        <a:t>개요(L.0), 기초(L.1–L.3), 구조(L.4–L.8), 생성 모델(L.9–L.13), 자기지도·규모(L.14–L.18), 멀티모달·로봇(L.19–L.21), travplan에서(L.22)</a:t>
+                        <a:t>개요(I.0), 데이터·리타기팅(I.1–I.6), 동작 추종(I.7–I.9), 범용 추종기(I.10–I.12), 위 층(I.13), travplan에서(I.14)</a:t>
                       </a:r>
                     </a:p>
                   </a:txBody>
@@ -7785,7 +7905,7 @@
                           <a:ea typeface="Malgun Gothic"/>
                           <a:cs typeface="Malgun Gothic"/>
                         </a:rPr>
-                        <a:t>교재 Understanding Deep Learning과 MIT 6.S184·Stanford CS336을 뼈대로 한 딥러닝 개념. 장난감 문제를 실제로 풀어 그린 그림</a:t>
+                        <a:t>사람 동작 데이터와 라이선스, 리타기팅(로봇 쪽 고전, GMR·OmniRetarget), 동작 추종(SAMCON·DeepMimic에서 BeyondMimic까지의 계보), 범용 추종기(SONIC, SuperMimic)와 2026년 후속, 공개 코드. 장난감 문제를 풀어 그린 그림</a:t>
                       </a:r>
                     </a:p>
                   </a:txBody>
@@ -7809,111 +7929,13 @@
                           <a:ea typeface="Malgun Gothic"/>
                           <a:cs typeface="Malgun Gothic"/>
                         </a:rPr>
-                        <a:t>Planner D(flow matching), Joint Planner(DiT식 transformer), TravNet, TinyPolicy의 구조와 학습</a:t>
+                        <a:t>학습 절차(적응 표집, 교사–학생, world model을 통한 정책 기울기), Planner·Controller 분리, Playground 휴머노이드</a:t>
                       </a:r>
                     </a:p>
                   </a:txBody>
                   <a:tcPr marL="63500" marR="63500" marT="12700" marB="12700">
                     <a:solidFill>
                       <a:srgbClr val="F3F0E8"/>
-                    </a:solidFill>
-                  </a:tcPr>
-                </a:tc>
-              </a:tr>
-              <a:tr h="438864">
-                <a:tc>
-                  <a:txBody>
-                    <a:bodyPr wrap="square"/>
-                    <a:lstStyle/>
-                    <a:p>
-                      <a:r>
-                        <a:rPr sz="800" b="0" i="0">
-                          <a:solidFill>
-                            <a:srgbClr val="16213A"/>
-                          </a:solidFill>
-                          <a:latin typeface="Arial"/>
-                          <a:ea typeface="Malgun Gothic"/>
-                          <a:cs typeface="Malgun Gothic"/>
-                        </a:rPr>
-                        <a:t>모방 (§I)</a:t>
-                      </a:r>
-                    </a:p>
-                  </a:txBody>
-                  <a:tcPr marL="63500" marR="63500" marT="12700" marB="12700">
-                    <a:solidFill>
-                      <a:srgbClr val="FFFDF8"/>
-                    </a:solidFill>
-                  </a:tcPr>
-                </a:tc>
-                <a:tc>
-                  <a:txBody>
-                    <a:bodyPr wrap="square"/>
-                    <a:lstStyle/>
-                    <a:p>
-                      <a:r>
-                        <a:rPr sz="800" b="0" i="0">
-                          <a:solidFill>
-                            <a:srgbClr val="16213A"/>
-                          </a:solidFill>
-                          <a:latin typeface="Arial"/>
-                          <a:ea typeface="Malgun Gothic"/>
-                          <a:cs typeface="Malgun Gothic"/>
-                        </a:rPr>
-                        <a:t>개요(I.0), 데이터·리타기팅(I.1–I.6), 동작 추종(I.7–I.9), 범용 추종기(I.10–I.12), 위 층(I.13), travplan에서(I.14)</a:t>
-                      </a:r>
-                    </a:p>
-                  </a:txBody>
-                  <a:tcPr marL="63500" marR="63500" marT="12700" marB="12700">
-                    <a:solidFill>
-                      <a:srgbClr val="FFFDF8"/>
-                    </a:solidFill>
-                  </a:tcPr>
-                </a:tc>
-                <a:tc>
-                  <a:txBody>
-                    <a:bodyPr wrap="square"/>
-                    <a:lstStyle/>
-                    <a:p>
-                      <a:r>
-                        <a:rPr sz="800" b="0" i="0">
-                          <a:solidFill>
-                            <a:srgbClr val="16213A"/>
-                          </a:solidFill>
-                          <a:latin typeface="Arial"/>
-                          <a:ea typeface="Malgun Gothic"/>
-                          <a:cs typeface="Malgun Gothic"/>
-                        </a:rPr>
-                        <a:t>사람 동작 데이터와 라이선스, 리타기팅(로봇 쪽 고전, GMR·OmniRetarget), 동작 추종(SAMCON·DeepMimic에서 BeyondMimic까지의 계보), 범용 추종기(SONIC, SuperMimic)와 2026년 후속, 공개 코드. 장난감 문제를 풀어 그린 그림</a:t>
-                      </a:r>
-                    </a:p>
-                  </a:txBody>
-                  <a:tcPr marL="63500" marR="63500" marT="12700" marB="12700">
-                    <a:solidFill>
-                      <a:srgbClr val="FFFDF8"/>
-                    </a:solidFill>
-                  </a:tcPr>
-                </a:tc>
-                <a:tc>
-                  <a:txBody>
-                    <a:bodyPr wrap="square"/>
-                    <a:lstStyle/>
-                    <a:p>
-                      <a:r>
-                        <a:rPr sz="800" b="0" i="0">
-                          <a:solidFill>
-                            <a:srgbClr val="16213A"/>
-                          </a:solidFill>
-                          <a:latin typeface="Arial"/>
-                          <a:ea typeface="Malgun Gothic"/>
-                          <a:cs typeface="Malgun Gothic"/>
-                        </a:rPr>
-                        <a:t>학습 절차(적응 표집, 교사–학생, world model을 통한 정책 기울기), Planner·Controller 분리, Playground 휴머노이드</a:t>
-                      </a:r>
-                    </a:p>
-                  </a:txBody>
-                  <a:tcPr marL="63500" marR="63500" marT="12700" marB="12700">
-                    <a:solidFill>
-                      <a:srgbClr val="FFFDF8"/>
                     </a:solidFill>
                   </a:tcPr>
                 </a:tc>
@@ -7939,7 +7961,7 @@
                   </a:txBody>
                   <a:tcPr marL="63500" marR="63500" marT="12700" marB="12700">
                     <a:solidFill>
-                      <a:srgbClr val="F3F0E8"/>
+                      <a:srgbClr val="FFFDF8"/>
                     </a:solidFill>
                   </a:tcPr>
                 </a:tc>
@@ -7963,7 +7985,7 @@
                   </a:txBody>
                   <a:tcPr marL="63500" marR="63500" marT="12700" marB="12700">
                     <a:solidFill>
-                      <a:srgbClr val="F3F0E8"/>
+                      <a:srgbClr val="FFFDF8"/>
                     </a:solidFill>
                   </a:tcPr>
                 </a:tc>
@@ -7987,7 +8009,7 @@
                   </a:txBody>
                   <a:tcPr marL="63500" marR="63500" marT="12700" marB="12700">
                     <a:solidFill>
-                      <a:srgbClr val="F3F0E8"/>
+                      <a:srgbClr val="FFFDF8"/>
                     </a:solidFill>
                   </a:tcPr>
                 </a:tc>
@@ -8011,7 +8033,7 @@
                   </a:txBody>
                   <a:tcPr marL="63500" marR="63500" marT="12700" marB="12700">
                     <a:solidFill>
-                      <a:srgbClr val="F3F0E8"/>
+                      <a:srgbClr val="FFFDF8"/>
                     </a:solidFill>
                   </a:tcPr>
                 </a:tc>
@@ -8028,7 +8050,7 @@
         </p:nvSpPr>
         <p:spPr>
           <a:xfrm>
-            <a:off x="609600" y="4424362"/>
+            <a:off x="609600" y="4821833"/>
             <a:ext cx="10972800" cy="432991"/>
           </a:xfrm>
           <a:prstGeom prst="rect">
@@ -8077,8 +8099,8 @@
           <p:nvPr/>
         </p:nvGraphicFramePr>
         <p:xfrm>
-          <a:off x="609600" y="4946253"/>
-          <a:ext cx="10966449" cy="833040"/>
+          <a:off x="609600" y="5343723"/>
+          <a:ext cx="10966449" cy="515064"/>
         </p:xfrm>
         <a:graphic>
           <a:graphicData uri="http://schemas.openxmlformats.org/drawingml/2006/table">
@@ -8333,128 +8355,6 @@
                   <a:tcPr marL="63500" marR="63500" marT="12700" marB="12700">
                     <a:solidFill>
                       <a:srgbClr val="FFFDF8"/>
-                    </a:solidFill>
-                  </a:tcPr>
-                </a:tc>
-              </a:tr>
-              <a:tr h="317976">
-                <a:tc>
-                  <a:txBody>
-                    <a:bodyPr wrap="square"/>
-                    <a:lstStyle/>
-                    <a:p>
-                      <a:r>
-                        <a:rPr sz="800" b="0" i="0">
-                          <a:solidFill>
-                            <a:srgbClr val="16213A"/>
-                          </a:solidFill>
-                          <a:latin typeface="Arial"/>
-                          <a:ea typeface="Malgun Gothic"/>
-                          <a:cs typeface="Malgun Gothic"/>
-                        </a:rPr>
-                        <a:t>2008–2014</a:t>
-                      </a:r>
-                    </a:p>
-                  </a:txBody>
-                  <a:tcPr marL="63500" marR="63500" marT="12700" marB="12700">
-                    <a:solidFill>
-                      <a:srgbClr val="F3F0E8"/>
-                    </a:solidFill>
-                  </a:tcPr>
-                </a:tc>
-                <a:tc>
-                  <a:txBody>
-                    <a:bodyPr wrap="square"/>
-                    <a:lstStyle/>
-                    <a:p>
-                      <a:r>
-                        <a:rPr sz="800" b="0" i="0">
-                          <a:solidFill>
-                            <a:srgbClr val="16213A"/>
-                          </a:solidFill>
-                          <a:latin typeface="Arial"/>
-                          <a:ea typeface="Malgun Gothic"/>
-                          <a:cs typeface="Malgun Gothic"/>
-                        </a:rPr>
-                        <a:t>Robot-centric elevation mapping</a:t>
-                      </a:r>
-                    </a:p>
-                  </a:txBody>
-                  <a:tcPr marL="63500" marR="63500" marT="12700" marB="12700">
-                    <a:solidFill>
-                      <a:srgbClr val="F3F0E8"/>
-                    </a:solidFill>
-                  </a:tcPr>
-                </a:tc>
-                <a:tc>
-                  <a:txBody>
-                    <a:bodyPr wrap="square"/>
-                    <a:lstStyle/>
-                    <a:p>
-                      <a:r>
-                        <a:rPr sz="800" b="0" i="0">
-                          <a:solidFill>
-                            <a:srgbClr val="16213A"/>
-                          </a:solidFill>
-                          <a:latin typeface="Arial"/>
-                          <a:ea typeface="Malgun Gothic"/>
-                          <a:cs typeface="Malgun Gothic"/>
-                        </a:rPr>
-                        <a:t>Hybrid A*, TEB</a:t>
-                      </a:r>
-                    </a:p>
-                  </a:txBody>
-                  <a:tcPr marL="63500" marR="63500" marT="12700" marB="12700">
-                    <a:solidFill>
-                      <a:srgbClr val="F3F0E8"/>
-                    </a:solidFill>
-                  </a:tcPr>
-                </a:tc>
-                <a:tc>
-                  <a:txBody>
-                    <a:bodyPr wrap="square"/>
-                    <a:lstStyle/>
-                    <a:p>
-                      <a:r>
-                        <a:rPr sz="800" b="0" i="0">
-                          <a:solidFill>
-                            <a:srgbClr val="16213A"/>
-                          </a:solidFill>
-                          <a:latin typeface="Arial"/>
-                          <a:ea typeface="Malgun Gothic"/>
-                          <a:cs typeface="Malgun Gothic"/>
-                        </a:rPr>
-                        <a:t>—</a:t>
-                      </a:r>
-                    </a:p>
-                  </a:txBody>
-                  <a:tcPr marL="63500" marR="63500" marT="12700" marB="12700">
-                    <a:solidFill>
-                      <a:srgbClr val="F3F0E8"/>
-                    </a:solidFill>
-                  </a:tcPr>
-                </a:tc>
-                <a:tc>
-                  <a:txBody>
-                    <a:bodyPr wrap="square"/>
-                    <a:lstStyle/>
-                    <a:p>
-                      <a:r>
-                        <a:rPr sz="800" b="0" i="0">
-                          <a:solidFill>
-                            <a:srgbClr val="16213A"/>
-                          </a:solidFill>
-                          <a:latin typeface="Arial"/>
-                          <a:ea typeface="Malgun Gothic"/>
-                          <a:cs typeface="Malgun Gothic"/>
-                        </a:rPr>
-                        <a:t>—</a:t>
-                      </a:r>
-                    </a:p>
-                  </a:txBody>
-                  <a:tcPr marL="63500" marR="63500" marT="12700" marB="12700">
-                    <a:solidFill>
-                      <a:srgbClr val="F3F0E8"/>
                     </a:solidFill>
                   </a:tcPr>
                 </a:tc>
@@ -8621,7 +8521,7 @@
         </p:nvGraphicFramePr>
         <p:xfrm>
           <a:off x="609600" y="1244600"/>
-          <a:ext cx="10966449" cy="2422920"/>
+          <a:ext cx="10966449" cy="2740896"/>
         </p:xfrm>
         <a:graphic>
           <a:graphicData uri="http://schemas.openxmlformats.org/drawingml/2006/table">
@@ -8773,7 +8673,7 @@
                           <a:ea typeface="Malgun Gothic"/>
                           <a:cs typeface="Malgun Gothic"/>
                         </a:rPr>
-                        <a:t>2015–2018</a:t>
+                        <a:t>2008–2014</a:t>
                       </a:r>
                     </a:p>
                   </a:txBody>
@@ -8797,7 +8697,7 @@
                           <a:ea typeface="Malgun Gothic"/>
                           <a:cs typeface="Malgun Gothic"/>
                         </a:rPr>
-                        <a:t>Social GAN</a:t>
+                        <a:t>Robot-centric elevation mapping</a:t>
                       </a:r>
                     </a:p>
                   </a:txBody>
@@ -8821,7 +8721,7 @@
                           <a:ea typeface="Malgun Gothic"/>
                           <a:cs typeface="Malgun Gothic"/>
                         </a:rPr>
-                        <a:t>Apollo EM planner</a:t>
+                        <a:t>Hybrid A*, TEB</a:t>
                       </a:r>
                     </a:p>
                   </a:txBody>
@@ -8845,7 +8745,7 @@
                           <a:ea typeface="Malgun Gothic"/>
                           <a:cs typeface="Malgun Gothic"/>
                         </a:rPr>
-                        <a:t>MPPI, 정보이론적 MPC, CBF-QP, HJ 도달 가능성, PETS, 예측 안전 필터</a:t>
+                        <a:t>—</a:t>
                       </a:r>
                     </a:p>
                   </a:txBody>
@@ -8869,7 +8769,7 @@
                           <a:ea typeface="Malgun Gothic"/>
                           <a:cs typeface="Malgun Gothic"/>
                         </a:rPr>
-                        <a:t>Sorour 등, Domain Randomization, Dynamics Randomization</a:t>
+                        <a:t>—</a:t>
                       </a:r>
                     </a:p>
                   </a:txBody>
@@ -8895,7 +8795,7 @@
                           <a:ea typeface="Malgun Gothic"/>
                           <a:cs typeface="Malgun Gothic"/>
                         </a:rPr>
-                        <a:t>2019–2020</a:t>
+                        <a:t>2015–2018</a:t>
                       </a:r>
                     </a:p>
                   </a:txBody>
@@ -8919,7 +8819,7 @@
                           <a:ea typeface="Malgun Gothic"/>
                           <a:cs typeface="Malgun Gothic"/>
                         </a:rPr>
-                        <a:t>Lift-Splat-Shoot, RELLIS-3D, BADGR, 등속 모델, Trajectron++</a:t>
+                        <a:t>Social GAN</a:t>
                       </a:r>
                     </a:p>
                   </a:txBody>
@@ -8943,7 +8843,7 @@
                           <a:ea typeface="Malgun Gothic"/>
                           <a:cs typeface="Malgun Gothic"/>
                         </a:rPr>
-                        <a:t>Nav2</a:t>
+                        <a:t>Apollo EM planner</a:t>
                       </a:r>
                     </a:p>
                   </a:txBody>
@@ -8967,7 +8867,7 @@
                           <a:ea typeface="Malgun Gothic"/>
                           <a:cs typeface="Malgun Gothic"/>
                         </a:rPr>
-                        <a:t>CBF 튜토리얼, 이산 CBF + MPC</a:t>
+                        <a:t>MPPI, 정보이론적 MPC, CBF-QP, HJ 도달 가능성, PETS, 예측 안전 필터</a:t>
                       </a:r>
                     </a:p>
                   </a:txBody>
@@ -8991,7 +8891,7 @@
                           <a:ea typeface="Malgun Gothic"/>
                           <a:cs typeface="Malgun Gothic"/>
                         </a:rPr>
-                        <a:t>Actuator net, ADR, Sim2Real Predictivity</a:t>
+                        <a:t>Sorour 등, Domain Randomization, Dynamics Randomization</a:t>
                       </a:r>
                     </a:p>
                   </a:txBody>
@@ -9017,7 +8917,7 @@
                           <a:ea typeface="Malgun Gothic"/>
                           <a:cs typeface="Malgun Gothic"/>
                         </a:rPr>
-                        <a:t>2021–2022</a:t>
+                        <a:t>2019–2020</a:t>
                       </a:r>
                     </a:p>
                   </a:txBody>
@@ -9041,7 +8941,7 @@
                           <a:ea typeface="Malgun Gothic"/>
                           <a:cs typeface="Malgun Gothic"/>
                         </a:rPr>
-                        <a:t>BEVFormer, BEVFusion, MonoScene, elevation_mapping_cupy, ByteTrack, BoT-SORT</a:t>
+                        <a:t>Lift-Splat-Shoot, RELLIS-3D, BADGR, 등속 모델, Trajectron++</a:t>
                       </a:r>
                     </a:p>
                   </a:txBody>
@@ -9065,7 +8965,7 @@
                           <a:ea typeface="Malgun Gothic"/>
                           <a:cs typeface="Malgun Gothic"/>
                         </a:rPr>
-                        <a:t>Diffuser, GNM, FAR Planner, PUTN</a:t>
+                        <a:t>Nav2</a:t>
                       </a:r>
                     </a:p>
                   </a:txBody>
@@ -9089,7 +8989,7 @@
                           <a:ea typeface="Malgun Gothic"/>
                           <a:cs typeface="Malgun Gothic"/>
                         </a:rPr>
-                        <a:t>Robust MPPI, IKD, RMA, log-MPPI, SMPPI</a:t>
+                        <a:t>CBF 튜토리얼, 이산 CBF + MPC</a:t>
                       </a:r>
                     </a:p>
                   </a:txBody>
@@ -9113,7 +9013,7 @@
                           <a:ea typeface="Malgun Gothic"/>
                           <a:cs typeface="Malgun Gothic"/>
                         </a:rPr>
-                        <a:t>Learning to Walk in Minutes, ART/ATK</a:t>
+                        <a:t>Actuator net, ADR, Sim2Real Predictivity</a:t>
                       </a:r>
                     </a:p>
                   </a:txBody>
@@ -9139,7 +9039,7 @@
                           <a:ea typeface="Malgun Gothic"/>
                           <a:cs typeface="Malgun Gothic"/>
                         </a:rPr>
-                        <a:t>2023</a:t>
+                        <a:t>2021–2022</a:t>
                       </a:r>
                     </a:p>
                   </a:txBody>
@@ -9163,7 +9063,7 @@
                           <a:ea typeface="Malgun Gothic"/>
                           <a:cs typeface="Malgun Gothic"/>
                         </a:rPr>
-                        <a:t>DINOv2, Grounding DINO, Occ3D, WVN, RT-DETR</a:t>
+                        <a:t>BEVFormer, BEVFusion, MonoScene, elevation_mapping_cupy, ByteTrack, BoT-SORT</a:t>
                       </a:r>
                     </a:p>
                   </a:txBody>
@@ -9187,7 +9087,7 @@
                           <a:ea typeface="Malgun Gothic"/>
                           <a:cs typeface="Malgun Gothic"/>
                         </a:rPr>
-                        <a:t>iPlanner, ViNT, NoMaD, Diffusion Policy, MPD, UniAD, VAD, PDM-Closed, ArtPlanner</a:t>
+                        <a:t>Diffuser, GNM, FAR Planner, PUTN</a:t>
                       </a:r>
                     </a:p>
                   </a:txBody>
@@ -9211,7 +9111,7 @@
                           <a:ea typeface="Malgun Gothic"/>
                           <a:cs typeface="Malgun Gothic"/>
                         </a:rPr>
-                        <a:t>TD-MPC2, 안전 필터 통합 관점</a:t>
+                        <a:t>Robust MPPI, IKD, RMA, log-MPPI, SMPPI</a:t>
                       </a:r>
                     </a:p>
                   </a:txBody>
@@ -9235,7 +9135,7 @@
                           <a:ea typeface="Malgun Gothic"/>
                           <a:cs typeface="Malgun Gothic"/>
                         </a:rPr>
-                        <a:t>HuNavSim, Gazebo Harmonic</a:t>
+                        <a:t>Learning to Walk in Minutes, ART/ATK</a:t>
                       </a:r>
                     </a:p>
                   </a:txBody>
@@ -9261,7 +9161,7 @@
                           <a:ea typeface="Malgun Gothic"/>
                           <a:cs typeface="Malgun Gothic"/>
                         </a:rPr>
-                        <a:t>2024</a:t>
+                        <a:t>2023</a:t>
                       </a:r>
                     </a:p>
                   </a:txBody>
@@ -9285,7 +9185,7 @@
                           <a:ea typeface="Malgun Gothic"/>
                           <a:cs typeface="Malgun Gothic"/>
                         </a:rPr>
-                        <a:t>Depth Anything V2, SAM 2, V-STRONG, RoadRunner, YOLOv10, D-FINE</a:t>
+                        <a:t>DINOv2, Grounding DINO, Occ3D, WVN, RT-DETR</a:t>
                       </a:r>
                     </a:p>
                   </a:txBody>
@@ -9309,7 +9209,7 @@
                           <a:ea typeface="Malgun Gothic"/>
                           <a:cs typeface="Malgun Gothic"/>
                         </a:rPr>
-                        <a:t>ViPlanner, OpenVLA, π0, NaVILA, CityWalker, DiffusionDrive, NAVSIM, Hydra-MDP</a:t>
+                        <a:t>iPlanner, ViNT, NoMaD, Diffusion Policy, MPD, UniAD, VAD, PDM-Closed, ArtPlanner</a:t>
                       </a:r>
                     </a:p>
                   </a:txBody>
@@ -9333,7 +9233,7 @@
                           <a:ea typeface="Malgun Gothic"/>
                           <a:cs typeface="Malgun Gothic"/>
                         </a:rPr>
-                        <a:t>MPPI-Generic</a:t>
+                        <a:t>TD-MPC2, 안전 필터 통합 관점</a:t>
                       </a:r>
                     </a:p>
                   </a:txBody>
@@ -9357,7 +9257,7 @@
                           <a:ea typeface="Malgun Gothic"/>
                           <a:cs typeface="Malgun Gothic"/>
                         </a:rPr>
-                        <a:t>MetaUrban, Arena 4.0, X-Mobility, Navigation World Models</a:t>
+                        <a:t>HuNavSim, Gazebo Harmonic</a:t>
                       </a:r>
                     </a:p>
                   </a:txBody>
@@ -9383,7 +9283,7 @@
                           <a:ea typeface="Malgun Gothic"/>
                           <a:cs typeface="Malgun Gothic"/>
                         </a:rPr>
-                        <a:t>2025</a:t>
+                        <a:t>2024</a:t>
                       </a:r>
                     </a:p>
                   </a:txBody>
@@ -9407,7 +9307,7 @@
                           <a:ea typeface="Malgun Gothic"/>
                           <a:cs typeface="Malgun Gothic"/>
                         </a:rPr>
-                        <a:t>DINOv3, Depth Anything 3, SAM 3, RF-DETR, MoFlow</a:t>
+                        <a:t>Depth Anything V2, SAM 2, V-STRONG, RoadRunner, YOLOv10, D-FINE</a:t>
                       </a:r>
                     </a:p>
                   </a:txBody>
@@ -9431,7 +9331,7 @@
                           <a:ea typeface="Malgun Gothic"/>
                           <a:cs typeface="Malgun Gothic"/>
                         </a:rPr>
-                        <a:t>Diffusion Planner, GoalFlow, NavDP, CaRL, Alpamayo, MolmoAct, VAMOS, FPO</a:t>
+                        <a:t>ViPlanner, OpenVLA, π0, NaVILA, CityWalker, DiffusionDrive, NAVSIM, Hydra-MDP</a:t>
                       </a:r>
                     </a:p>
                   </a:txBody>
@@ -9455,7 +9355,7 @@
                           <a:ea typeface="Malgun Gothic"/>
                           <a:cs typeface="Malgun Gothic"/>
                         </a:rPr>
-                        <a:t>CVaR-BF, DRA-MPPI</a:t>
+                        <a:t>MPPI-Generic</a:t>
                       </a:r>
                     </a:p>
                   </a:txBody>
@@ -9479,7 +9379,7 @@
                           <a:ea typeface="Malgun Gothic"/>
                           <a:cs typeface="Malgun Gothic"/>
                         </a:rPr>
-                        <a:t>Isaac Lab, MuJoCo Playground, URBAN-SIM, UrbanVerse, COMPASS, Cosmos</a:t>
+                        <a:t>MetaUrban, Arena 4.0, X-Mobility, Navigation World Models</a:t>
                       </a:r>
                     </a:p>
                   </a:txBody>
@@ -9505,13 +9405,135 @@
                           <a:ea typeface="Malgun Gothic"/>
                           <a:cs typeface="Malgun Gothic"/>
                         </a:rPr>
+                        <a:t>2025</a:t>
+                      </a:r>
+                    </a:p>
+                  </a:txBody>
+                  <a:tcPr marL="63500" marR="63500" marT="12700" marB="12700">
+                    <a:solidFill>
+                      <a:srgbClr val="FFFDF8"/>
+                    </a:solidFill>
+                  </a:tcPr>
+                </a:tc>
+                <a:tc>
+                  <a:txBody>
+                    <a:bodyPr wrap="square"/>
+                    <a:lstStyle/>
+                    <a:p>
+                      <a:r>
+                        <a:rPr sz="800" b="0" i="0">
+                          <a:solidFill>
+                            <a:srgbClr val="16213A"/>
+                          </a:solidFill>
+                          <a:latin typeface="Arial"/>
+                          <a:ea typeface="Malgun Gothic"/>
+                          <a:cs typeface="Malgun Gothic"/>
+                        </a:rPr>
+                        <a:t>DINOv3, Depth Anything 3, SAM 3, RF-DETR, MoFlow</a:t>
+                      </a:r>
+                    </a:p>
+                  </a:txBody>
+                  <a:tcPr marL="63500" marR="63500" marT="12700" marB="12700">
+                    <a:solidFill>
+                      <a:srgbClr val="FFFDF8"/>
+                    </a:solidFill>
+                  </a:tcPr>
+                </a:tc>
+                <a:tc>
+                  <a:txBody>
+                    <a:bodyPr wrap="square"/>
+                    <a:lstStyle/>
+                    <a:p>
+                      <a:r>
+                        <a:rPr sz="800" b="0" i="0">
+                          <a:solidFill>
+                            <a:srgbClr val="16213A"/>
+                          </a:solidFill>
+                          <a:latin typeface="Arial"/>
+                          <a:ea typeface="Malgun Gothic"/>
+                          <a:cs typeface="Malgun Gothic"/>
+                        </a:rPr>
+                        <a:t>Diffusion Planner, GoalFlow, NavDP, CaRL, Alpamayo, MolmoAct, VAMOS, FPO</a:t>
+                      </a:r>
+                    </a:p>
+                  </a:txBody>
+                  <a:tcPr marL="63500" marR="63500" marT="12700" marB="12700">
+                    <a:solidFill>
+                      <a:srgbClr val="FFFDF8"/>
+                    </a:solidFill>
+                  </a:tcPr>
+                </a:tc>
+                <a:tc>
+                  <a:txBody>
+                    <a:bodyPr wrap="square"/>
+                    <a:lstStyle/>
+                    <a:p>
+                      <a:r>
+                        <a:rPr sz="800" b="0" i="0">
+                          <a:solidFill>
+                            <a:srgbClr val="16213A"/>
+                          </a:solidFill>
+                          <a:latin typeface="Arial"/>
+                          <a:ea typeface="Malgun Gothic"/>
+                          <a:cs typeface="Malgun Gothic"/>
+                        </a:rPr>
+                        <a:t>CVaR-BF, DRA-MPPI</a:t>
+                      </a:r>
+                    </a:p>
+                  </a:txBody>
+                  <a:tcPr marL="63500" marR="63500" marT="12700" marB="12700">
+                    <a:solidFill>
+                      <a:srgbClr val="FFFDF8"/>
+                    </a:solidFill>
+                  </a:tcPr>
+                </a:tc>
+                <a:tc>
+                  <a:txBody>
+                    <a:bodyPr wrap="square"/>
+                    <a:lstStyle/>
+                    <a:p>
+                      <a:r>
+                        <a:rPr sz="800" b="0" i="0">
+                          <a:solidFill>
+                            <a:srgbClr val="16213A"/>
+                          </a:solidFill>
+                          <a:latin typeface="Arial"/>
+                          <a:ea typeface="Malgun Gothic"/>
+                          <a:cs typeface="Malgun Gothic"/>
+                        </a:rPr>
+                        <a:t>Isaac Lab, MuJoCo Playground, URBAN-SIM, UrbanVerse, COMPASS, Cosmos</a:t>
+                      </a:r>
+                    </a:p>
+                  </a:txBody>
+                  <a:tcPr marL="63500" marR="63500" marT="12700" marB="12700">
+                    <a:solidFill>
+                      <a:srgbClr val="FFFDF8"/>
+                    </a:solidFill>
+                  </a:tcPr>
+                </a:tc>
+              </a:tr>
+              <a:tr h="317976">
+                <a:tc>
+                  <a:txBody>
+                    <a:bodyPr wrap="square"/>
+                    <a:lstStyle/>
+                    <a:p>
+                      <a:r>
+                        <a:rPr sz="800" b="0" i="0">
+                          <a:solidFill>
+                            <a:srgbClr val="16213A"/>
+                          </a:solidFill>
+                          <a:latin typeface="Arial"/>
+                          <a:ea typeface="Malgun Gothic"/>
+                          <a:cs typeface="Malgun Gothic"/>
+                        </a:rPr>
                         <a:t>2026</a:t>
                       </a:r>
                     </a:p>
                   </a:txBody>
                   <a:tcPr marL="63500" marR="63500" marT="12700" marB="12700">
                     <a:solidFill>
-                      <a:srgbClr val="FFFDF8"/>
+                      <a:srgbClr val="F3F0E8"/>
                     </a:solidFill>
                   </a:tcPr>
                 </a:tc>
@@ -9535,7 +9557,7 @@
                   </a:txBody>
                   <a:tcPr marL="63500" marR="63500" marT="12700" marB="12700">
                     <a:solidFill>
-                      <a:srgbClr val="FFFDF8"/>
+                      <a:srgbClr val="F3F0E8"/>
                     </a:solidFill>
                   </a:tcPr>
                 </a:tc>
@@ -9559,7 +9581,7 @@
                   </a:txBody>
                   <a:tcPr marL="63500" marR="63500" marT="12700" marB="12700">
                     <a:solidFill>
-                      <a:srgbClr val="FFFDF8"/>
+                      <a:srgbClr val="F3F0E8"/>
                     </a:solidFill>
                   </a:tcPr>
                 </a:tc>
@@ -9583,7 +9605,7 @@
                   </a:txBody>
                   <a:tcPr marL="63500" marR="63500" marT="12700" marB="12700">
                     <a:solidFill>
-                      <a:srgbClr val="FFFDF8"/>
+                      <a:srgbClr val="F3F0E8"/>
                     </a:solidFill>
                   </a:tcPr>
                 </a:tc>
@@ -9607,7 +9629,7 @@
                   </a:txBody>
                   <a:tcPr marL="63500" marR="63500" marT="12700" marB="12700">
                     <a:solidFill>
-                      <a:srgbClr val="FFFDF8"/>
+                      <a:srgbClr val="F3F0E8"/>
                     </a:solidFill>
                   </a:tcPr>
                 </a:tc>

</xml_diff>